<commit_message>
Refine documentation: update report formatting rules, enhance example usage guidelines, add detailed date format specifications, and include new recommendations for linking actions to outcomes. Update plugin version for changes.
</commit_message>
<xml_diff>
--- a/plugins/company-report/skills/company-report/assets/template.pptx
+++ b/plugins/company-report/skills/company-report/assets/template.pptx
@@ -2,18 +2,18 @@
 <file path=ppt/presentation.xml><?xml version="1.0" encoding="utf-8"?>
 <p:presentation xmlns:p="http://schemas.openxmlformats.org/presentationml/2006/main">
   <p:sldMasterIdLst>
-    <p:sldMasterId xmlns:r="http://schemas.openxmlformats.org/officeDocument/2006/relationships" id="2147483648" r:id="Rafb83df9b8c841cb"/>
+    <p:sldMasterId xmlns:r="http://schemas.openxmlformats.org/officeDocument/2006/relationships" id="2147483648" r:id="R7096ea6931a94f5c"/>
   </p:sldMasterIdLst>
   <p:notesMasterIdLst>
-    <p:notesMasterId xmlns:r="http://schemas.openxmlformats.org/officeDocument/2006/relationships" r:id="R1aa0a3e47d524784"/>
+    <p:notesMasterId xmlns:r="http://schemas.openxmlformats.org/officeDocument/2006/relationships" r:id="R02c33c7693884eb1"/>
   </p:notesMasterIdLst>
   <p:sldIdLst>
-    <p:sldId xmlns:r="http://schemas.openxmlformats.org/officeDocument/2006/relationships" id="256" r:id="R5a75695c11b54092"/>
-    <p:sldId xmlns:r="http://schemas.openxmlformats.org/officeDocument/2006/relationships" id="257" r:id="R5217b52641904506"/>
-    <p:sldId xmlns:r="http://schemas.openxmlformats.org/officeDocument/2006/relationships" id="258" r:id="R7d621f4ce3424e79"/>
-    <p:sldId xmlns:r="http://schemas.openxmlformats.org/officeDocument/2006/relationships" id="259" r:id="Rc9d1fd877e1245b3"/>
-    <p:sldId xmlns:r="http://schemas.openxmlformats.org/officeDocument/2006/relationships" id="260" r:id="Rf946d172b8b54b78"/>
-    <p:sldId xmlns:r="http://schemas.openxmlformats.org/officeDocument/2006/relationships" id="261" r:id="Ra7a54e172fb14b9d"/>
+    <p:sldId xmlns:r="http://schemas.openxmlformats.org/officeDocument/2006/relationships" id="256" r:id="Rd608c4c6f42c488e"/>
+    <p:sldId xmlns:r="http://schemas.openxmlformats.org/officeDocument/2006/relationships" id="257" r:id="Rb3532b4f36cb46ea"/>
+    <p:sldId xmlns:r="http://schemas.openxmlformats.org/officeDocument/2006/relationships" id="258" r:id="Rbc6c50f357274b5b"/>
+    <p:sldId xmlns:r="http://schemas.openxmlformats.org/officeDocument/2006/relationships" id="259" r:id="Rd438c0e25af54af4"/>
+    <p:sldId xmlns:r="http://schemas.openxmlformats.org/officeDocument/2006/relationships" id="260" r:id="Rd4c6b64dae0648be"/>
+    <p:sldId xmlns:r="http://schemas.openxmlformats.org/officeDocument/2006/relationships" id="261" r:id="R6bb55fe738aa4699"/>
   </p:sldIdLst>
   <p:sldSz cx="12192000" cy="6858000"/>
   <p:notesSz cx="6858000" cy="9144000"/>
@@ -936,7 +936,7 @@
   </p:cSld>
   <p:clrMap bg1="lt1" tx1="dk1" bg2="lt2" tx2="dk2" accent1="accent1" accent2="accent2" accent3="accent3" accent4="accent4" accent5="accent5" accent6="accent6" hlink="hlink" folHlink="folHlink"/>
   <p:sldLayoutIdLst>
-    <p:sldLayoutId xmlns:r="http://schemas.openxmlformats.org/officeDocument/2006/relationships" id="2147483649" r:id="R28540fe8da25436d"/>
+    <p:sldLayoutId xmlns:r="http://schemas.openxmlformats.org/officeDocument/2006/relationships" id="2147483649" r:id="R1d7a8e1ff8654119"/>
   </p:sldLayoutIdLst>
   <p:txStyles>
     <p:titleStyle>
@@ -1475,7 +1475,7 @@
     </p:bg>
     <p:spTree>
       <p:nvGrpSpPr>
-        <p:cNvPr id="1001" name="s1-root"/>
+        <p:cNvPr id="1" name=""/>
         <p:cNvGrpSpPr/>
         <p:nvPr/>
       </p:nvGrpSpPr>
@@ -1578,7 +1578,9 @@
           <a:bodyPr xmlns:a="http://schemas.openxmlformats.org/drawingml/2006/main" lIns="0" tIns="0" rIns="0" bIns="0" anchor="t"/>
           <a:lstStyle xmlns:a="http://schemas.openxmlformats.org/drawingml/2006/main"/>
           <a:p xmlns:a="http://schemas.openxmlformats.org/drawingml/2006/main">
-            <a:pPr algn="l"/>
+            <a:pPr algn="l">
+              <a:buNone/>
+            </a:pPr>
             <a:r>
               <a:rPr sz="3000" b="1" i="0">
                 <a:solidFill>
@@ -1656,7 +1658,9 @@
           <a:bodyPr xmlns:a="http://schemas.openxmlformats.org/drawingml/2006/main" lIns="0" tIns="0" rIns="0" bIns="0" anchor="t"/>
           <a:lstStyle xmlns:a="http://schemas.openxmlformats.org/drawingml/2006/main"/>
           <a:p xmlns:a="http://schemas.openxmlformats.org/drawingml/2006/main">
-            <a:pPr algn="l"/>
+            <a:pPr algn="l">
+              <a:buNone/>
+            </a:pPr>
             <a:r>
               <a:rPr sz="900" b="0" i="0">
                 <a:solidFill>
@@ -1703,7 +1707,9 @@
           <a:bodyPr xmlns:a="http://schemas.openxmlformats.org/drawingml/2006/main" lIns="0" tIns="0" rIns="0" bIns="0" anchor="t"/>
           <a:lstStyle xmlns:a="http://schemas.openxmlformats.org/drawingml/2006/main"/>
           <a:p xmlns:a="http://schemas.openxmlformats.org/drawingml/2006/main">
-            <a:pPr algn="r"/>
+            <a:pPr algn="r">
+              <a:buNone/>
+            </a:pPr>
             <a:r>
               <a:rPr sz="900" b="0" i="0">
                 <a:solidFill>
@@ -1781,7 +1787,9 @@
           <a:bodyPr xmlns:a="http://schemas.openxmlformats.org/drawingml/2006/main" lIns="0" tIns="0" rIns="0" bIns="0" anchor="t"/>
           <a:lstStyle xmlns:a="http://schemas.openxmlformats.org/drawingml/2006/main"/>
           <a:p xmlns:a="http://schemas.openxmlformats.org/drawingml/2006/main">
-            <a:pPr algn="l"/>
+            <a:pPr algn="l">
+              <a:buNone/>
+            </a:pPr>
             <a:r>
               <a:rPr sz="1800" b="1" i="0">
                 <a:solidFill>
@@ -1839,7 +1847,9 @@
           <a:bodyPr xmlns:a="http://schemas.openxmlformats.org/drawingml/2006/main" lIns="0" tIns="0" rIns="0" bIns="0" anchor="t"/>
           <a:lstStyle xmlns:a="http://schemas.openxmlformats.org/drawingml/2006/main"/>
           <a:p xmlns:a="http://schemas.openxmlformats.org/drawingml/2006/main">
-            <a:pPr algn="r"/>
+            <a:pPr algn="r">
+              <a:buNone/>
+            </a:pPr>
             <a:r>
               <a:rPr sz="1500" b="1" i="0">
                 <a:solidFill>
@@ -2012,7 +2022,9 @@
           <a:bodyPr xmlns:a="http://schemas.openxmlformats.org/drawingml/2006/main" lIns="0" tIns="0" rIns="0" bIns="0" anchor="t"/>
           <a:lstStyle xmlns:a="http://schemas.openxmlformats.org/drawingml/2006/main"/>
           <a:p xmlns:a="http://schemas.openxmlformats.org/drawingml/2006/main">
-            <a:pPr algn="ctr"/>
+            <a:pPr algn="ctr">
+              <a:buNone/>
+            </a:pPr>
             <a:r>
               <a:rPr sz="1700" b="1" i="0">
                 <a:solidFill>
@@ -2090,7 +2102,9 @@
           <a:bodyPr xmlns:a="http://schemas.openxmlformats.org/drawingml/2006/main" lIns="0" tIns="0" rIns="0" bIns="0" anchor="t"/>
           <a:lstStyle xmlns:a="http://schemas.openxmlformats.org/drawingml/2006/main"/>
           <a:p xmlns:a="http://schemas.openxmlformats.org/drawingml/2006/main">
-            <a:pPr algn="r"/>
+            <a:pPr algn="r">
+              <a:buNone/>
+            </a:pPr>
             <a:r>
               <a:rPr sz="800" b="1" i="0">
                 <a:solidFill>
@@ -2137,7 +2151,9 @@
           <a:bodyPr xmlns:a="http://schemas.openxmlformats.org/drawingml/2006/main" lIns="0" tIns="0" rIns="0" bIns="0" anchor="t"/>
           <a:lstStyle xmlns:a="http://schemas.openxmlformats.org/drawingml/2006/main"/>
           <a:p xmlns:a="http://schemas.openxmlformats.org/drawingml/2006/main">
-            <a:pPr algn="ctr"/>
+            <a:pPr algn="ctr">
+              <a:buNone/>
+            </a:pPr>
             <a:r>
               <a:rPr sz="2000" b="1" i="0">
                 <a:solidFill>
@@ -2184,7 +2200,9 @@
           <a:bodyPr xmlns:a="http://schemas.openxmlformats.org/drawingml/2006/main" lIns="0" tIns="0" rIns="0" bIns="0" anchor="t"/>
           <a:lstStyle xmlns:a="http://schemas.openxmlformats.org/drawingml/2006/main"/>
           <a:p xmlns:a="http://schemas.openxmlformats.org/drawingml/2006/main">
-            <a:pPr algn="l"/>
+            <a:pPr algn="l">
+              <a:buNone/>
+            </a:pPr>
             <a:r>
               <a:rPr sz="1200" b="1" i="0">
                 <a:solidFill>
@@ -2231,7 +2249,9 @@
           <a:bodyPr xmlns:a="http://schemas.openxmlformats.org/drawingml/2006/main" lIns="0" tIns="0" rIns="0" bIns="0" anchor="t"/>
           <a:lstStyle xmlns:a="http://schemas.openxmlformats.org/drawingml/2006/main"/>
           <a:p xmlns:a="http://schemas.openxmlformats.org/drawingml/2006/main">
-            <a:pPr algn="r"/>
+            <a:pPr algn="r">
+              <a:buNone/>
+            </a:pPr>
             <a:r>
               <a:rPr sz="800" b="1" i="0">
                 <a:solidFill>
@@ -2278,7 +2298,9 @@
           <a:bodyPr xmlns:a="http://schemas.openxmlformats.org/drawingml/2006/main" lIns="0" tIns="0" rIns="0" bIns="0" anchor="t"/>
           <a:lstStyle xmlns:a="http://schemas.openxmlformats.org/drawingml/2006/main"/>
           <a:p xmlns:a="http://schemas.openxmlformats.org/drawingml/2006/main">
-            <a:pPr algn="ctr"/>
+            <a:pPr algn="ctr">
+              <a:buNone/>
+            </a:pPr>
             <a:r>
               <a:rPr sz="2000" b="1" i="0">
                 <a:solidFill>
@@ -2325,7 +2347,9 @@
           <a:bodyPr xmlns:a="http://schemas.openxmlformats.org/drawingml/2006/main" lIns="0" tIns="0" rIns="0" bIns="0" anchor="t"/>
           <a:lstStyle xmlns:a="http://schemas.openxmlformats.org/drawingml/2006/main"/>
           <a:p xmlns:a="http://schemas.openxmlformats.org/drawingml/2006/main">
-            <a:pPr algn="l"/>
+            <a:pPr algn="l">
+              <a:buNone/>
+            </a:pPr>
             <a:r>
               <a:rPr sz="1200" b="1" i="0">
                 <a:solidFill>
@@ -2372,7 +2396,9 @@
           <a:bodyPr xmlns:a="http://schemas.openxmlformats.org/drawingml/2006/main" lIns="0" tIns="0" rIns="0" bIns="0" anchor="t"/>
           <a:lstStyle xmlns:a="http://schemas.openxmlformats.org/drawingml/2006/main"/>
           <a:p xmlns:a="http://schemas.openxmlformats.org/drawingml/2006/main">
-            <a:pPr algn="r"/>
+            <a:pPr algn="r">
+              <a:buNone/>
+            </a:pPr>
             <a:r>
               <a:rPr sz="800" b="1" i="0">
                 <a:solidFill>
@@ -2419,7 +2445,9 @@
           <a:bodyPr xmlns:a="http://schemas.openxmlformats.org/drawingml/2006/main" lIns="0" tIns="0" rIns="0" bIns="0" anchor="t"/>
           <a:lstStyle xmlns:a="http://schemas.openxmlformats.org/drawingml/2006/main"/>
           <a:p xmlns:a="http://schemas.openxmlformats.org/drawingml/2006/main">
-            <a:pPr algn="ctr"/>
+            <a:pPr algn="ctr">
+              <a:buNone/>
+            </a:pPr>
             <a:r>
               <a:rPr sz="2000" b="1" i="0">
                 <a:solidFill>
@@ -2466,7 +2494,9 @@
           <a:bodyPr xmlns:a="http://schemas.openxmlformats.org/drawingml/2006/main" lIns="0" tIns="0" rIns="0" bIns="0" anchor="t"/>
           <a:lstStyle xmlns:a="http://schemas.openxmlformats.org/drawingml/2006/main"/>
           <a:p xmlns:a="http://schemas.openxmlformats.org/drawingml/2006/main">
-            <a:pPr algn="l"/>
+            <a:pPr algn="l">
+              <a:buNone/>
+            </a:pPr>
             <a:r>
               <a:rPr sz="1200" b="1" i="0">
                 <a:solidFill>
@@ -2513,7 +2543,9 @@
           <a:bodyPr xmlns:a="http://schemas.openxmlformats.org/drawingml/2006/main" lIns="0" tIns="0" rIns="0" bIns="0" anchor="t"/>
           <a:lstStyle xmlns:a="http://schemas.openxmlformats.org/drawingml/2006/main"/>
           <a:p xmlns:a="http://schemas.openxmlformats.org/drawingml/2006/main">
-            <a:pPr algn="r"/>
+            <a:pPr algn="r">
+              <a:buNone/>
+            </a:pPr>
             <a:r>
               <a:rPr sz="800" b="1" i="0">
                 <a:solidFill>
@@ -2560,7 +2592,9 @@
           <a:bodyPr xmlns:a="http://schemas.openxmlformats.org/drawingml/2006/main" lIns="0" tIns="0" rIns="0" bIns="0" anchor="t"/>
           <a:lstStyle xmlns:a="http://schemas.openxmlformats.org/drawingml/2006/main"/>
           <a:p xmlns:a="http://schemas.openxmlformats.org/drawingml/2006/main">
-            <a:pPr algn="ctr"/>
+            <a:pPr algn="ctr">
+              <a:buNone/>
+            </a:pPr>
             <a:r>
               <a:rPr sz="2000" b="1" i="0">
                 <a:solidFill>
@@ -2607,7 +2641,9 @@
           <a:bodyPr xmlns:a="http://schemas.openxmlformats.org/drawingml/2006/main" lIns="0" tIns="0" rIns="0" bIns="0" anchor="t"/>
           <a:lstStyle xmlns:a="http://schemas.openxmlformats.org/drawingml/2006/main"/>
           <a:p xmlns:a="http://schemas.openxmlformats.org/drawingml/2006/main">
-            <a:pPr algn="l"/>
+            <a:pPr algn="l">
+              <a:buNone/>
+            </a:pPr>
             <a:r>
               <a:rPr sz="1200" b="1" i="0">
                 <a:solidFill>
@@ -2685,7 +2721,9 @@
           <a:bodyPr xmlns:a="http://schemas.openxmlformats.org/drawingml/2006/main" lIns="0" tIns="0" rIns="0" bIns="0" anchor="t"/>
           <a:lstStyle xmlns:a="http://schemas.openxmlformats.org/drawingml/2006/main"/>
           <a:p xmlns:a="http://schemas.openxmlformats.org/drawingml/2006/main">
-            <a:pPr algn="l"/>
+            <a:pPr algn="l">
+              <a:buNone/>
+            </a:pPr>
             <a:r>
               <a:rPr sz="1000" b="1" i="0">
                 <a:solidFill>
@@ -2929,7 +2967,9 @@
           <a:bodyPr xmlns:a="http://schemas.openxmlformats.org/drawingml/2006/main" lIns="0" tIns="0" rIns="0" bIns="0" anchor="t"/>
           <a:lstStyle xmlns:a="http://schemas.openxmlformats.org/drawingml/2006/main"/>
           <a:p xmlns:a="http://schemas.openxmlformats.org/drawingml/2006/main">
-            <a:pPr algn="ctr"/>
+            <a:pPr algn="ctr">
+              <a:buNone/>
+            </a:pPr>
             <a:r>
               <a:rPr sz="1700" b="1" i="0">
                 <a:solidFill>
@@ -2976,7 +3016,9 @@
           <a:bodyPr xmlns:a="http://schemas.openxmlformats.org/drawingml/2006/main" lIns="0" tIns="0" rIns="0" bIns="0" anchor="t"/>
           <a:lstStyle xmlns:a="http://schemas.openxmlformats.org/drawingml/2006/main"/>
           <a:p xmlns:a="http://schemas.openxmlformats.org/drawingml/2006/main">
-            <a:pPr algn="l"/>
+            <a:pPr algn="l">
+              <a:buNone/>
+            </a:pPr>
             <a:r>
               <a:rPr sz="1100" b="1" i="0">
                 <a:solidFill>
@@ -2986,7 +3028,7 @@
                 <a:ea typeface="NanumBarunGothicOTF"/>
                 <a:cs typeface="NanumBarunGothicOTF"/>
               </a:rPr>
-              <a:t>■ 기간: YYYY.MM.DD ~ YYYY.MM.DD</a:t>
+              <a:t>■ 기간: YYYY-MM-DD ~ YYYY-MM-DD</a:t>
             </a:r>
           </a:p>
         </p:txBody>
@@ -3023,7 +3065,9 @@
           <a:bodyPr xmlns:a="http://schemas.openxmlformats.org/drawingml/2006/main" lIns="0" tIns="0" rIns="0" bIns="0" anchor="t"/>
           <a:lstStyle xmlns:a="http://schemas.openxmlformats.org/drawingml/2006/main"/>
           <a:p xmlns:a="http://schemas.openxmlformats.org/drawingml/2006/main">
-            <a:pPr algn="l"/>
+            <a:pPr algn="l">
+              <a:buNone/>
+            </a:pPr>
             <a:r>
               <a:rPr sz="1100" b="1" i="0">
                 <a:solidFill>
@@ -3070,7 +3114,9 @@
           <a:bodyPr xmlns:a="http://schemas.openxmlformats.org/drawingml/2006/main" lIns="0" tIns="0" rIns="0" bIns="0" anchor="t"/>
           <a:lstStyle xmlns:a="http://schemas.openxmlformats.org/drawingml/2006/main"/>
           <a:p xmlns:a="http://schemas.openxmlformats.org/drawingml/2006/main">
-            <a:pPr algn="l"/>
+            <a:pPr algn="l">
+              <a:buNone/>
+            </a:pPr>
             <a:r>
               <a:rPr sz="1200" b="1" i="0">
                 <a:solidFill>
@@ -3117,7 +3163,9 @@
           <a:bodyPr xmlns:a="http://schemas.openxmlformats.org/drawingml/2006/main" lIns="0" tIns="0" rIns="0" bIns="0" anchor="t"/>
           <a:lstStyle xmlns:a="http://schemas.openxmlformats.org/drawingml/2006/main"/>
           <a:p xmlns:a="http://schemas.openxmlformats.org/drawingml/2006/main">
-            <a:pPr algn="l"/>
+            <a:pPr algn="l">
+              <a:buNone/>
+            </a:pPr>
             <a:r>
               <a:rPr sz="1400" b="1" i="0">
                 <a:solidFill>
@@ -3164,7 +3212,9 @@
           <a:bodyPr xmlns:a="http://schemas.openxmlformats.org/drawingml/2006/main" lIns="0" tIns="0" rIns="0" bIns="0" anchor="t"/>
           <a:lstStyle xmlns:a="http://schemas.openxmlformats.org/drawingml/2006/main"/>
           <a:p xmlns:a="http://schemas.openxmlformats.org/drawingml/2006/main">
-            <a:pPr algn="l"/>
+            <a:pPr algn="l">
+              <a:buNone/>
+            </a:pPr>
             <a:r>
               <a:rPr sz="1000" b="0" i="0">
                 <a:solidFill>
@@ -3244,7 +3294,9 @@
           <a:bodyPr xmlns:a="http://schemas.openxmlformats.org/drawingml/2006/main" lIns="0" tIns="0" rIns="0" bIns="0" anchor="t"/>
           <a:lstStyle xmlns:a="http://schemas.openxmlformats.org/drawingml/2006/main"/>
           <a:p xmlns:a="http://schemas.openxmlformats.org/drawingml/2006/main">
-            <a:pPr algn="ctr"/>
+            <a:pPr algn="ctr">
+              <a:buNone/>
+            </a:pPr>
             <a:r>
               <a:rPr sz="1000" b="1" i="0">
                 <a:solidFill>
@@ -3324,7 +3376,9 @@
           <a:bodyPr xmlns:a="http://schemas.openxmlformats.org/drawingml/2006/main" lIns="0" tIns="0" rIns="0" bIns="0" anchor="t"/>
           <a:lstStyle xmlns:a="http://schemas.openxmlformats.org/drawingml/2006/main"/>
           <a:p xmlns:a="http://schemas.openxmlformats.org/drawingml/2006/main">
-            <a:pPr algn="ctr"/>
+            <a:pPr algn="ctr">
+              <a:buNone/>
+            </a:pPr>
             <a:r>
               <a:rPr sz="1000" b="1" i="0">
                 <a:solidFill>
@@ -3404,7 +3458,9 @@
           <a:bodyPr xmlns:a="http://schemas.openxmlformats.org/drawingml/2006/main" lIns="0" tIns="0" rIns="0" bIns="0" anchor="t"/>
           <a:lstStyle xmlns:a="http://schemas.openxmlformats.org/drawingml/2006/main"/>
           <a:p xmlns:a="http://schemas.openxmlformats.org/drawingml/2006/main">
-            <a:pPr algn="ctr"/>
+            <a:pPr algn="ctr">
+              <a:buNone/>
+            </a:pPr>
             <a:r>
               <a:rPr sz="1000" b="1" i="0">
                 <a:solidFill>
@@ -3414,7 +3470,7 @@
                 <a:ea typeface="NanumBarunGothicOTF"/>
                 <a:cs typeface="NanumBarunGothicOTF"/>
               </a:rPr>
-              <a:t>조치 및 남은 과제</a:t>
+              <a:t>조치·개선 및 남은 과제</a:t>
             </a:r>
           </a:p>
         </p:txBody>
@@ -3484,7 +3540,9 @@
           <a:bodyPr xmlns:a="http://schemas.openxmlformats.org/drawingml/2006/main" lIns="0" tIns="0" rIns="0" bIns="0" anchor="t"/>
           <a:lstStyle xmlns:a="http://schemas.openxmlformats.org/drawingml/2006/main"/>
           <a:p xmlns:a="http://schemas.openxmlformats.org/drawingml/2006/main">
-            <a:pPr algn="ctr"/>
+            <a:pPr algn="ctr">
+              <a:buNone/>
+            </a:pPr>
             <a:r>
               <a:rPr sz="1000" b="1" i="0">
                 <a:solidFill>
@@ -3564,7 +3622,9 @@
           <a:bodyPr xmlns:a="http://schemas.openxmlformats.org/drawingml/2006/main" lIns="0" tIns="0" rIns="0" bIns="0" anchor="t"/>
           <a:lstStyle xmlns:a="http://schemas.openxmlformats.org/drawingml/2006/main"/>
           <a:p xmlns:a="http://schemas.openxmlformats.org/drawingml/2006/main">
-            <a:pPr algn="l"/>
+            <a:pPr algn="l">
+              <a:buNone/>
+            </a:pPr>
             <a:r>
               <a:rPr sz="1000" b="0" i="0">
                 <a:solidFill>
@@ -3574,7 +3634,7 @@
                 <a:ea typeface="NanumBarunGothicOTF"/>
                 <a:cs typeface="NanumBarunGothicOTF"/>
               </a:rPr>
-              <a:t>[확인된 사실·원인]</a:t>
+              <a:t>[사실·원인·예시]</a:t>
             </a:r>
           </a:p>
         </p:txBody>
@@ -3644,7 +3704,9 @@
           <a:bodyPr xmlns:a="http://schemas.openxmlformats.org/drawingml/2006/main" lIns="0" tIns="0" rIns="0" bIns="0" anchor="t"/>
           <a:lstStyle xmlns:a="http://schemas.openxmlformats.org/drawingml/2006/main"/>
           <a:p xmlns:a="http://schemas.openxmlformats.org/drawingml/2006/main">
-            <a:pPr algn="l"/>
+            <a:pPr algn="l">
+              <a:buNone/>
+            </a:pPr>
             <a:r>
               <a:rPr sz="1000" b="0" i="0">
                 <a:solidFill>
@@ -3654,7 +3716,7 @@
                 <a:ea typeface="NanumBarunGothicOTF"/>
                 <a:cs typeface="NanumBarunGothicOTF"/>
               </a:rPr>
-              <a:t>[조치·남은 과제]</a:t>
+              <a:t>[조치·개선·남은 과제]</a:t>
             </a:r>
           </a:p>
         </p:txBody>
@@ -3724,7 +3786,9 @@
           <a:bodyPr xmlns:a="http://schemas.openxmlformats.org/drawingml/2006/main" lIns="0" tIns="0" rIns="0" bIns="0" anchor="t"/>
           <a:lstStyle xmlns:a="http://schemas.openxmlformats.org/drawingml/2006/main"/>
           <a:p xmlns:a="http://schemas.openxmlformats.org/drawingml/2006/main">
-            <a:pPr algn="ctr"/>
+            <a:pPr algn="ctr">
+              <a:buNone/>
+            </a:pPr>
             <a:r>
               <a:rPr sz="1000" b="1" i="0">
                 <a:solidFill>
@@ -3804,7 +3868,9 @@
           <a:bodyPr xmlns:a="http://schemas.openxmlformats.org/drawingml/2006/main" lIns="0" tIns="0" rIns="0" bIns="0" anchor="t"/>
           <a:lstStyle xmlns:a="http://schemas.openxmlformats.org/drawingml/2006/main"/>
           <a:p xmlns:a="http://schemas.openxmlformats.org/drawingml/2006/main">
-            <a:pPr algn="l"/>
+            <a:pPr algn="l">
+              <a:buNone/>
+            </a:pPr>
             <a:r>
               <a:rPr sz="1000" b="0" i="0">
                 <a:solidFill>
@@ -3814,7 +3880,7 @@
                 <a:ea typeface="NanumBarunGothicOTF"/>
                 <a:cs typeface="NanumBarunGothicOTF"/>
               </a:rPr>
-              <a:t>[확인된 사실·원인]</a:t>
+              <a:t>[사실·원인·예시]</a:t>
             </a:r>
           </a:p>
         </p:txBody>
@@ -3884,7 +3950,9 @@
           <a:bodyPr xmlns:a="http://schemas.openxmlformats.org/drawingml/2006/main" lIns="0" tIns="0" rIns="0" bIns="0" anchor="t"/>
           <a:lstStyle xmlns:a="http://schemas.openxmlformats.org/drawingml/2006/main"/>
           <a:p xmlns:a="http://schemas.openxmlformats.org/drawingml/2006/main">
-            <a:pPr algn="l"/>
+            <a:pPr algn="l">
+              <a:buNone/>
+            </a:pPr>
             <a:r>
               <a:rPr sz="1000" b="0" i="0">
                 <a:solidFill>
@@ -3894,7 +3962,7 @@
                 <a:ea typeface="NanumBarunGothicOTF"/>
                 <a:cs typeface="NanumBarunGothicOTF"/>
               </a:rPr>
-              <a:t>[조치·남은 과제]</a:t>
+              <a:t>[조치·개선·남은 과제]</a:t>
             </a:r>
           </a:p>
         </p:txBody>
@@ -3964,7 +4032,9 @@
           <a:bodyPr xmlns:a="http://schemas.openxmlformats.org/drawingml/2006/main" lIns="0" tIns="0" rIns="0" bIns="0" anchor="t"/>
           <a:lstStyle xmlns:a="http://schemas.openxmlformats.org/drawingml/2006/main"/>
           <a:p xmlns:a="http://schemas.openxmlformats.org/drawingml/2006/main">
-            <a:pPr algn="ctr"/>
+            <a:pPr algn="ctr">
+              <a:buNone/>
+            </a:pPr>
             <a:r>
               <a:rPr sz="1000" b="1" i="0">
                 <a:solidFill>
@@ -4044,7 +4114,9 @@
           <a:bodyPr xmlns:a="http://schemas.openxmlformats.org/drawingml/2006/main" lIns="0" tIns="0" rIns="0" bIns="0" anchor="t"/>
           <a:lstStyle xmlns:a="http://schemas.openxmlformats.org/drawingml/2006/main"/>
           <a:p xmlns:a="http://schemas.openxmlformats.org/drawingml/2006/main">
-            <a:pPr algn="l"/>
+            <a:pPr algn="l">
+              <a:buNone/>
+            </a:pPr>
             <a:r>
               <a:rPr sz="1000" b="0" i="0">
                 <a:solidFill>
@@ -4054,7 +4126,7 @@
                 <a:ea typeface="NanumBarunGothicOTF"/>
                 <a:cs typeface="NanumBarunGothicOTF"/>
               </a:rPr>
-              <a:t>[확인된 사실·원인]</a:t>
+              <a:t>[사실·원인·예시]</a:t>
             </a:r>
           </a:p>
         </p:txBody>
@@ -4124,7 +4196,9 @@
           <a:bodyPr xmlns:a="http://schemas.openxmlformats.org/drawingml/2006/main" lIns="0" tIns="0" rIns="0" bIns="0" anchor="t"/>
           <a:lstStyle xmlns:a="http://schemas.openxmlformats.org/drawingml/2006/main"/>
           <a:p xmlns:a="http://schemas.openxmlformats.org/drawingml/2006/main">
-            <a:pPr algn="l"/>
+            <a:pPr algn="l">
+              <a:buNone/>
+            </a:pPr>
             <a:r>
               <a:rPr sz="1000" b="0" i="0">
                 <a:solidFill>
@@ -4134,7 +4208,7 @@
                 <a:ea typeface="NanumBarunGothicOTF"/>
                 <a:cs typeface="NanumBarunGothicOTF"/>
               </a:rPr>
-              <a:t>[조치·남은 과제]</a:t>
+              <a:t>[조치·개선·남은 과제]</a:t>
             </a:r>
           </a:p>
         </p:txBody>
@@ -4161,7 +4235,7 @@
     </p:bg>
     <p:spTree>
       <p:nvGrpSpPr>
-        <p:cNvPr id="2001" name="s2-root"/>
+        <p:cNvPr id="1" name=""/>
         <p:cNvGrpSpPr/>
         <p:nvPr/>
       </p:nvGrpSpPr>
@@ -4264,7 +4338,9 @@
           <a:bodyPr xmlns:a="http://schemas.openxmlformats.org/drawingml/2006/main" lIns="0" tIns="0" rIns="0" bIns="0" anchor="t"/>
           <a:lstStyle xmlns:a="http://schemas.openxmlformats.org/drawingml/2006/main"/>
           <a:p xmlns:a="http://schemas.openxmlformats.org/drawingml/2006/main">
-            <a:pPr algn="l"/>
+            <a:pPr algn="l">
+              <a:buNone/>
+            </a:pPr>
             <a:r>
               <a:rPr sz="3000" b="1" i="0">
                 <a:solidFill>
@@ -4342,7 +4418,9 @@
           <a:bodyPr xmlns:a="http://schemas.openxmlformats.org/drawingml/2006/main" lIns="0" tIns="0" rIns="0" bIns="0" anchor="t"/>
           <a:lstStyle xmlns:a="http://schemas.openxmlformats.org/drawingml/2006/main"/>
           <a:p xmlns:a="http://schemas.openxmlformats.org/drawingml/2006/main">
-            <a:pPr algn="l"/>
+            <a:pPr algn="l">
+              <a:buNone/>
+            </a:pPr>
             <a:r>
               <a:rPr sz="900" b="0" i="0">
                 <a:solidFill>
@@ -4389,7 +4467,9 @@
           <a:bodyPr xmlns:a="http://schemas.openxmlformats.org/drawingml/2006/main" lIns="0" tIns="0" rIns="0" bIns="0" anchor="t"/>
           <a:lstStyle xmlns:a="http://schemas.openxmlformats.org/drawingml/2006/main"/>
           <a:p xmlns:a="http://schemas.openxmlformats.org/drawingml/2006/main">
-            <a:pPr algn="r"/>
+            <a:pPr algn="r">
+              <a:buNone/>
+            </a:pPr>
             <a:r>
               <a:rPr sz="900" b="0" i="0">
                 <a:solidFill>
@@ -4467,7 +4547,9 @@
           <a:bodyPr xmlns:a="http://schemas.openxmlformats.org/drawingml/2006/main" lIns="0" tIns="0" rIns="0" bIns="0" anchor="t"/>
           <a:lstStyle xmlns:a="http://schemas.openxmlformats.org/drawingml/2006/main"/>
           <a:p xmlns:a="http://schemas.openxmlformats.org/drawingml/2006/main">
-            <a:pPr algn="ctr"/>
+            <a:pPr algn="ctr">
+              <a:buNone/>
+            </a:pPr>
             <a:r>
               <a:rPr sz="2000" b="1" i="0">
                 <a:solidFill>
@@ -4477,7 +4559,7 @@
                 <a:ea typeface="NanumBarunGothicOTF"/>
                 <a:cs typeface="NanumBarunGothicOTF"/>
               </a:rPr>
-              <a:t>[과제명 또는 개선 업무명]</a:t>
+              <a:t>[핵심 결론: 개선 내용·효과·다음 조치]</a:t>
             </a:r>
           </a:p>
         </p:txBody>
@@ -4640,7 +4722,9 @@
           <a:bodyPr xmlns:a="http://schemas.openxmlformats.org/drawingml/2006/main" lIns="0" tIns="0" rIns="0" bIns="0" anchor="t"/>
           <a:lstStyle xmlns:a="http://schemas.openxmlformats.org/drawingml/2006/main"/>
           <a:p xmlns:a="http://schemas.openxmlformats.org/drawingml/2006/main">
-            <a:pPr algn="ctr"/>
+            <a:pPr algn="ctr">
+              <a:buNone/>
+            </a:pPr>
             <a:r>
               <a:rPr sz="1700" b="1" i="0">
                 <a:solidFill>
@@ -4687,7 +4771,9 @@
           <a:bodyPr xmlns:a="http://schemas.openxmlformats.org/drawingml/2006/main" lIns="0" tIns="0" rIns="0" bIns="0" anchor="t"/>
           <a:lstStyle xmlns:a="http://schemas.openxmlformats.org/drawingml/2006/main"/>
           <a:p xmlns:a="http://schemas.openxmlformats.org/drawingml/2006/main">
-            <a:pPr algn="l"/>
+            <a:pPr algn="l">
+              <a:buNone/>
+            </a:pPr>
             <a:r>
               <a:rPr sz="1100" b="1" i="0">
                 <a:solidFill>
@@ -4734,7 +4820,9 @@
           <a:bodyPr xmlns:a="http://schemas.openxmlformats.org/drawingml/2006/main" lIns="0" tIns="0" rIns="0" bIns="0" anchor="t"/>
           <a:lstStyle xmlns:a="http://schemas.openxmlformats.org/drawingml/2006/main"/>
           <a:p xmlns:a="http://schemas.openxmlformats.org/drawingml/2006/main">
-            <a:pPr algn="ctr"/>
+            <a:pPr algn="ctr">
+              <a:buNone/>
+            </a:pPr>
             <a:r>
               <a:rPr sz="1500" b="1" i="0">
                 <a:solidFill>
@@ -4852,7 +4940,9 @@
           <a:bodyPr xmlns:a="http://schemas.openxmlformats.org/drawingml/2006/main" lIns="0" tIns="0" rIns="0" bIns="0" anchor="t"/>
           <a:lstStyle xmlns:a="http://schemas.openxmlformats.org/drawingml/2006/main"/>
           <a:p xmlns:a="http://schemas.openxmlformats.org/drawingml/2006/main">
-            <a:pPr algn="ctr"/>
+            <a:pPr algn="ctr">
+              <a:buNone/>
+            </a:pPr>
             <a:r>
               <a:rPr sz="2400" b="1" i="0">
                 <a:solidFill>
@@ -4930,7 +5020,9 @@
           <a:bodyPr xmlns:a="http://schemas.openxmlformats.org/drawingml/2006/main" lIns="0" tIns="0" rIns="0" bIns="0" anchor="t"/>
           <a:lstStyle xmlns:a="http://schemas.openxmlformats.org/drawingml/2006/main"/>
           <a:p xmlns:a="http://schemas.openxmlformats.org/drawingml/2006/main">
-            <a:pPr algn="l"/>
+            <a:pPr algn="l">
+              <a:buNone/>
+            </a:pPr>
             <a:r>
               <a:rPr sz="1100" b="1" i="0">
                 <a:solidFill>
@@ -4977,7 +5069,9 @@
           <a:bodyPr xmlns:a="http://schemas.openxmlformats.org/drawingml/2006/main" lIns="0" tIns="0" rIns="0" bIns="0" anchor="t"/>
           <a:lstStyle xmlns:a="http://schemas.openxmlformats.org/drawingml/2006/main"/>
           <a:p xmlns:a="http://schemas.openxmlformats.org/drawingml/2006/main">
-            <a:pPr algn="ctr"/>
+            <a:pPr algn="ctr">
+              <a:buNone/>
+            </a:pPr>
             <a:r>
               <a:rPr sz="1500" b="1" i="0">
                 <a:solidFill>
@@ -5126,7 +5220,9 @@
           <a:bodyPr xmlns:a="http://schemas.openxmlformats.org/drawingml/2006/main" lIns="0" tIns="0" rIns="0" bIns="0" anchor="t"/>
           <a:lstStyle xmlns:a="http://schemas.openxmlformats.org/drawingml/2006/main"/>
           <a:p xmlns:a="http://schemas.openxmlformats.org/drawingml/2006/main">
-            <a:pPr algn="ctr"/>
+            <a:pPr algn="ctr">
+              <a:buNone/>
+            </a:pPr>
             <a:r>
               <a:rPr sz="1200" b="1" i="0">
                 <a:solidFill>
@@ -5215,7 +5311,9 @@
           <a:bodyPr xmlns:a="http://schemas.openxmlformats.org/drawingml/2006/main" lIns="0" tIns="0" rIns="0" bIns="0" anchor="t"/>
           <a:lstStyle xmlns:a="http://schemas.openxmlformats.org/drawingml/2006/main"/>
           <a:p xmlns:a="http://schemas.openxmlformats.org/drawingml/2006/main">
-            <a:pPr algn="l"/>
+            <a:pPr algn="l">
+              <a:buNone/>
+            </a:pPr>
             <a:r>
               <a:rPr sz="1500" b="1" i="0">
                 <a:solidFill>
@@ -5293,7 +5391,9 @@
           <a:bodyPr xmlns:a="http://schemas.openxmlformats.org/drawingml/2006/main" lIns="0" tIns="0" rIns="0" bIns="0" anchor="t"/>
           <a:lstStyle xmlns:a="http://schemas.openxmlformats.org/drawingml/2006/main"/>
           <a:p xmlns:a="http://schemas.openxmlformats.org/drawingml/2006/main">
-            <a:pPr algn="ctr"/>
+            <a:pPr algn="ctr">
+              <a:buNone/>
+            </a:pPr>
             <a:r>
               <a:rPr sz="1000" b="1" i="0">
                 <a:solidFill>
@@ -5340,7 +5440,9 @@
           <a:bodyPr xmlns:a="http://schemas.openxmlformats.org/drawingml/2006/main" lIns="0" tIns="0" rIns="0" bIns="0" anchor="t"/>
           <a:lstStyle xmlns:a="http://schemas.openxmlformats.org/drawingml/2006/main"/>
           <a:p xmlns:a="http://schemas.openxmlformats.org/drawingml/2006/main">
-            <a:pPr algn="ctr"/>
+            <a:pPr algn="ctr">
+              <a:buNone/>
+            </a:pPr>
             <a:r>
               <a:rPr sz="2000" b="1" i="0">
                 <a:solidFill>
@@ -5387,7 +5489,9 @@
           <a:bodyPr xmlns:a="http://schemas.openxmlformats.org/drawingml/2006/main" lIns="0" tIns="0" rIns="0" bIns="0" anchor="t"/>
           <a:lstStyle xmlns:a="http://schemas.openxmlformats.org/drawingml/2006/main"/>
           <a:p xmlns:a="http://schemas.openxmlformats.org/drawingml/2006/main">
-            <a:pPr algn="ctr"/>
+            <a:pPr algn="ctr">
+              <a:buNone/>
+            </a:pPr>
             <a:r>
               <a:rPr sz="800" b="0" i="0">
                 <a:solidFill>
@@ -5434,7 +5538,9 @@
           <a:bodyPr xmlns:a="http://schemas.openxmlformats.org/drawingml/2006/main" lIns="0" tIns="0" rIns="0" bIns="0" anchor="t"/>
           <a:lstStyle xmlns:a="http://schemas.openxmlformats.org/drawingml/2006/main"/>
           <a:p xmlns:a="http://schemas.openxmlformats.org/drawingml/2006/main">
-            <a:pPr algn="ctr"/>
+            <a:pPr algn="ctr">
+              <a:buNone/>
+            </a:pPr>
             <a:r>
               <a:rPr sz="1000" b="1" i="0">
                 <a:solidFill>
@@ -5481,7 +5587,9 @@
           <a:bodyPr xmlns:a="http://schemas.openxmlformats.org/drawingml/2006/main" lIns="0" tIns="0" rIns="0" bIns="0" anchor="t"/>
           <a:lstStyle xmlns:a="http://schemas.openxmlformats.org/drawingml/2006/main"/>
           <a:p xmlns:a="http://schemas.openxmlformats.org/drawingml/2006/main">
-            <a:pPr algn="ctr"/>
+            <a:pPr algn="ctr">
+              <a:buNone/>
+            </a:pPr>
             <a:r>
               <a:rPr sz="2000" b="1" i="0">
                 <a:solidFill>
@@ -5528,7 +5636,9 @@
           <a:bodyPr xmlns:a="http://schemas.openxmlformats.org/drawingml/2006/main" lIns="0" tIns="0" rIns="0" bIns="0" anchor="t"/>
           <a:lstStyle xmlns:a="http://schemas.openxmlformats.org/drawingml/2006/main"/>
           <a:p xmlns:a="http://schemas.openxmlformats.org/drawingml/2006/main">
-            <a:pPr algn="ctr"/>
+            <a:pPr algn="ctr">
+              <a:buNone/>
+            </a:pPr>
             <a:r>
               <a:rPr sz="800" b="0" i="0">
                 <a:solidFill>
@@ -5575,7 +5685,9 @@
           <a:bodyPr xmlns:a="http://schemas.openxmlformats.org/drawingml/2006/main" lIns="0" tIns="0" rIns="0" bIns="0" anchor="t"/>
           <a:lstStyle xmlns:a="http://schemas.openxmlformats.org/drawingml/2006/main"/>
           <a:p xmlns:a="http://schemas.openxmlformats.org/drawingml/2006/main">
-            <a:pPr algn="ctr"/>
+            <a:pPr algn="ctr">
+              <a:buNone/>
+            </a:pPr>
             <a:r>
               <a:rPr sz="1000" b="1" i="0">
                 <a:solidFill>
@@ -5622,7 +5734,9 @@
           <a:bodyPr xmlns:a="http://schemas.openxmlformats.org/drawingml/2006/main" lIns="0" tIns="0" rIns="0" bIns="0" anchor="t"/>
           <a:lstStyle xmlns:a="http://schemas.openxmlformats.org/drawingml/2006/main"/>
           <a:p xmlns:a="http://schemas.openxmlformats.org/drawingml/2006/main">
-            <a:pPr algn="ctr"/>
+            <a:pPr algn="ctr">
+              <a:buNone/>
+            </a:pPr>
             <a:r>
               <a:rPr sz="2000" b="1" i="0">
                 <a:solidFill>
@@ -5669,7 +5783,9 @@
           <a:bodyPr xmlns:a="http://schemas.openxmlformats.org/drawingml/2006/main" lIns="0" tIns="0" rIns="0" bIns="0" anchor="t"/>
           <a:lstStyle xmlns:a="http://schemas.openxmlformats.org/drawingml/2006/main"/>
           <a:p xmlns:a="http://schemas.openxmlformats.org/drawingml/2006/main">
-            <a:pPr algn="ctr"/>
+            <a:pPr algn="ctr">
+              <a:buNone/>
+            </a:pPr>
             <a:r>
               <a:rPr sz="800" b="0" i="0">
                 <a:solidFill>
@@ -5716,7 +5832,9 @@
           <a:bodyPr xmlns:a="http://schemas.openxmlformats.org/drawingml/2006/main" lIns="0" tIns="0" rIns="0" bIns="0" anchor="t"/>
           <a:lstStyle xmlns:a="http://schemas.openxmlformats.org/drawingml/2006/main"/>
           <a:p xmlns:a="http://schemas.openxmlformats.org/drawingml/2006/main">
-            <a:pPr algn="ctr"/>
+            <a:pPr algn="ctr">
+              <a:buNone/>
+            </a:pPr>
             <a:r>
               <a:rPr sz="1000" b="1" i="0">
                 <a:solidFill>
@@ -5763,7 +5881,9 @@
           <a:bodyPr xmlns:a="http://schemas.openxmlformats.org/drawingml/2006/main" lIns="0" tIns="0" rIns="0" bIns="0" anchor="t"/>
           <a:lstStyle xmlns:a="http://schemas.openxmlformats.org/drawingml/2006/main"/>
           <a:p xmlns:a="http://schemas.openxmlformats.org/drawingml/2006/main">
-            <a:pPr algn="ctr"/>
+            <a:pPr algn="ctr">
+              <a:buNone/>
+            </a:pPr>
             <a:r>
               <a:rPr sz="2000" b="1" i="0">
                 <a:solidFill>
@@ -5810,7 +5930,9 @@
           <a:bodyPr xmlns:a="http://schemas.openxmlformats.org/drawingml/2006/main" lIns="0" tIns="0" rIns="0" bIns="0" anchor="t"/>
           <a:lstStyle xmlns:a="http://schemas.openxmlformats.org/drawingml/2006/main"/>
           <a:p xmlns:a="http://schemas.openxmlformats.org/drawingml/2006/main">
-            <a:pPr algn="ctr"/>
+            <a:pPr algn="ctr">
+              <a:buNone/>
+            </a:pPr>
             <a:r>
               <a:rPr sz="800" b="0" i="0">
                 <a:solidFill>
@@ -5888,7 +6010,9 @@
           <a:bodyPr xmlns:a="http://schemas.openxmlformats.org/drawingml/2006/main" lIns="0" tIns="0" rIns="0" bIns="0" anchor="t"/>
           <a:lstStyle xmlns:a="http://schemas.openxmlformats.org/drawingml/2006/main"/>
           <a:p xmlns:a="http://schemas.openxmlformats.org/drawingml/2006/main">
-            <a:pPr algn="l"/>
+            <a:pPr algn="l">
+              <a:buNone/>
+            </a:pPr>
             <a:r>
               <a:rPr sz="1500" b="1" i="0">
                 <a:solidFill>
@@ -5968,7 +6092,9 @@
           <a:bodyPr xmlns:a="http://schemas.openxmlformats.org/drawingml/2006/main" lIns="0" tIns="0" rIns="0" bIns="0" anchor="t"/>
           <a:lstStyle xmlns:a="http://schemas.openxmlformats.org/drawingml/2006/main"/>
           <a:p xmlns:a="http://schemas.openxmlformats.org/drawingml/2006/main">
-            <a:pPr algn="ctr"/>
+            <a:pPr algn="ctr">
+              <a:buNone/>
+            </a:pPr>
             <a:r>
               <a:rPr sz="1300" b="1" i="0">
                 <a:solidFill>
@@ -6015,7 +6141,9 @@
           <a:bodyPr xmlns:a="http://schemas.openxmlformats.org/drawingml/2006/main" lIns="0" tIns="0" rIns="0" bIns="0" anchor="t"/>
           <a:lstStyle xmlns:a="http://schemas.openxmlformats.org/drawingml/2006/main"/>
           <a:p xmlns:a="http://schemas.openxmlformats.org/drawingml/2006/main">
-            <a:pPr algn="ctr"/>
+            <a:pPr algn="ctr">
+              <a:buNone/>
+            </a:pPr>
             <a:r>
               <a:rPr sz="900" b="0" i="0">
                 <a:solidFill>
@@ -6062,7 +6190,9 @@
           <a:bodyPr xmlns:a="http://schemas.openxmlformats.org/drawingml/2006/main" lIns="0" tIns="0" rIns="0" bIns="0" anchor="t"/>
           <a:lstStyle xmlns:a="http://schemas.openxmlformats.org/drawingml/2006/main"/>
           <a:p xmlns:a="http://schemas.openxmlformats.org/drawingml/2006/main">
-            <a:pPr algn="ctr"/>
+            <a:pPr algn="ctr">
+              <a:buNone/>
+            </a:pPr>
             <a:r>
               <a:rPr sz="1700" b="1" i="0">
                 <a:solidFill>
@@ -6142,7 +6272,9 @@
           <a:bodyPr xmlns:a="http://schemas.openxmlformats.org/drawingml/2006/main" lIns="0" tIns="0" rIns="0" bIns="0" anchor="t"/>
           <a:lstStyle xmlns:a="http://schemas.openxmlformats.org/drawingml/2006/main"/>
           <a:p xmlns:a="http://schemas.openxmlformats.org/drawingml/2006/main">
-            <a:pPr algn="ctr"/>
+            <a:pPr algn="ctr">
+              <a:buNone/>
+            </a:pPr>
             <a:r>
               <a:rPr sz="1300" b="1" i="0">
                 <a:solidFill>
@@ -6189,7 +6321,9 @@
           <a:bodyPr xmlns:a="http://schemas.openxmlformats.org/drawingml/2006/main" lIns="0" tIns="0" rIns="0" bIns="0" anchor="t"/>
           <a:lstStyle xmlns:a="http://schemas.openxmlformats.org/drawingml/2006/main"/>
           <a:p xmlns:a="http://schemas.openxmlformats.org/drawingml/2006/main">
-            <a:pPr algn="ctr"/>
+            <a:pPr algn="ctr">
+              <a:buNone/>
+            </a:pPr>
             <a:r>
               <a:rPr sz="900" b="0" i="0">
                 <a:solidFill>
@@ -6236,7 +6370,9 @@
           <a:bodyPr xmlns:a="http://schemas.openxmlformats.org/drawingml/2006/main" lIns="0" tIns="0" rIns="0" bIns="0" anchor="t"/>
           <a:lstStyle xmlns:a="http://schemas.openxmlformats.org/drawingml/2006/main"/>
           <a:p xmlns:a="http://schemas.openxmlformats.org/drawingml/2006/main">
-            <a:pPr algn="ctr"/>
+            <a:pPr algn="ctr">
+              <a:buNone/>
+            </a:pPr>
             <a:r>
               <a:rPr sz="1700" b="1" i="0">
                 <a:solidFill>
@@ -6316,7 +6452,9 @@
           <a:bodyPr xmlns:a="http://schemas.openxmlformats.org/drawingml/2006/main" lIns="0" tIns="0" rIns="0" bIns="0" anchor="t"/>
           <a:lstStyle xmlns:a="http://schemas.openxmlformats.org/drawingml/2006/main"/>
           <a:p xmlns:a="http://schemas.openxmlformats.org/drawingml/2006/main">
-            <a:pPr algn="ctr"/>
+            <a:pPr algn="ctr">
+              <a:buNone/>
+            </a:pPr>
             <a:r>
               <a:rPr sz="1300" b="1" i="0">
                 <a:solidFill>
@@ -6363,7 +6501,9 @@
           <a:bodyPr xmlns:a="http://schemas.openxmlformats.org/drawingml/2006/main" lIns="0" tIns="0" rIns="0" bIns="0" anchor="t"/>
           <a:lstStyle xmlns:a="http://schemas.openxmlformats.org/drawingml/2006/main"/>
           <a:p xmlns:a="http://schemas.openxmlformats.org/drawingml/2006/main">
-            <a:pPr algn="ctr"/>
+            <a:pPr algn="ctr">
+              <a:buNone/>
+            </a:pPr>
             <a:r>
               <a:rPr sz="900" b="0" i="0">
                 <a:solidFill>
@@ -6410,7 +6550,9 @@
           <a:bodyPr xmlns:a="http://schemas.openxmlformats.org/drawingml/2006/main" lIns="0" tIns="0" rIns="0" bIns="0" anchor="t"/>
           <a:lstStyle xmlns:a="http://schemas.openxmlformats.org/drawingml/2006/main"/>
           <a:p xmlns:a="http://schemas.openxmlformats.org/drawingml/2006/main">
-            <a:pPr algn="l"/>
+            <a:pPr algn="l">
+              <a:buNone/>
+            </a:pPr>
             <a:r>
               <a:rPr sz="1100" b="1" i="0">
                 <a:solidFill>
@@ -6468,7 +6610,9 @@
           <a:bodyPr xmlns:a="http://schemas.openxmlformats.org/drawingml/2006/main" lIns="0" tIns="0" rIns="0" bIns="0" anchor="t"/>
           <a:lstStyle xmlns:a="http://schemas.openxmlformats.org/drawingml/2006/main"/>
           <a:p xmlns:a="http://schemas.openxmlformats.org/drawingml/2006/main">
-            <a:pPr algn="l"/>
+            <a:pPr algn="l">
+              <a:buNone/>
+            </a:pPr>
             <a:r>
               <a:rPr sz="1100" b="1" i="0">
                 <a:solidFill>
@@ -6526,7 +6670,9 @@
           <a:bodyPr xmlns:a="http://schemas.openxmlformats.org/drawingml/2006/main" lIns="0" tIns="0" rIns="0" bIns="0" anchor="t"/>
           <a:lstStyle xmlns:a="http://schemas.openxmlformats.org/drawingml/2006/main"/>
           <a:p xmlns:a="http://schemas.openxmlformats.org/drawingml/2006/main">
-            <a:pPr algn="l"/>
+            <a:pPr algn="l">
+              <a:buNone/>
+            </a:pPr>
             <a:r>
               <a:rPr sz="1100" b="1" i="0">
                 <a:solidFill>
@@ -6615,7 +6761,9 @@
           <a:bodyPr xmlns:a="http://schemas.openxmlformats.org/drawingml/2006/main" lIns="0" tIns="0" rIns="0" bIns="0" anchor="t"/>
           <a:lstStyle xmlns:a="http://schemas.openxmlformats.org/drawingml/2006/main"/>
           <a:p xmlns:a="http://schemas.openxmlformats.org/drawingml/2006/main">
-            <a:pPr algn="l"/>
+            <a:pPr algn="l">
+              <a:buNone/>
+            </a:pPr>
             <a:r>
               <a:rPr sz="1500" b="1" i="0">
                 <a:solidFill>
@@ -6693,7 +6841,9 @@
           <a:bodyPr xmlns:a="http://schemas.openxmlformats.org/drawingml/2006/main" lIns="0" tIns="0" rIns="0" bIns="0" anchor="t"/>
           <a:lstStyle xmlns:a="http://schemas.openxmlformats.org/drawingml/2006/main"/>
           <a:p xmlns:a="http://schemas.openxmlformats.org/drawingml/2006/main">
-            <a:pPr algn="ctr"/>
+            <a:pPr algn="ctr">
+              <a:buNone/>
+            </a:pPr>
             <a:r>
               <a:rPr sz="1300" b="1" i="0">
                 <a:solidFill>
@@ -6894,7 +7044,9 @@
           <a:bodyPr xmlns:a="http://schemas.openxmlformats.org/drawingml/2006/main" lIns="0" tIns="0" rIns="0" bIns="0" anchor="t"/>
           <a:lstStyle xmlns:a="http://schemas.openxmlformats.org/drawingml/2006/main"/>
           <a:p xmlns:a="http://schemas.openxmlformats.org/drawingml/2006/main">
-            <a:pPr algn="ctr"/>
+            <a:pPr algn="ctr">
+              <a:buNone/>
+            </a:pPr>
             <a:r>
               <a:rPr sz="1300" b="1" i="0">
                 <a:solidFill>
@@ -7095,7 +7247,9 @@
           <a:bodyPr xmlns:a="http://schemas.openxmlformats.org/drawingml/2006/main" lIns="0" tIns="0" rIns="0" bIns="0" anchor="t"/>
           <a:lstStyle xmlns:a="http://schemas.openxmlformats.org/drawingml/2006/main"/>
           <a:p xmlns:a="http://schemas.openxmlformats.org/drawingml/2006/main">
-            <a:pPr algn="ctr"/>
+            <a:pPr algn="ctr">
+              <a:buNone/>
+            </a:pPr>
             <a:r>
               <a:rPr sz="1300" b="1" i="0">
                 <a:solidFill>
@@ -7296,7 +7450,9 @@
           <a:bodyPr xmlns:a="http://schemas.openxmlformats.org/drawingml/2006/main" lIns="0" tIns="0" rIns="0" bIns="0" anchor="t"/>
           <a:lstStyle xmlns:a="http://schemas.openxmlformats.org/drawingml/2006/main"/>
           <a:p xmlns:a="http://schemas.openxmlformats.org/drawingml/2006/main">
-            <a:pPr algn="ctr"/>
+            <a:pPr algn="ctr">
+              <a:buNone/>
+            </a:pPr>
             <a:r>
               <a:rPr sz="1100" b="1" i="0">
                 <a:solidFill>
@@ -7333,7 +7489,7 @@
     </p:bg>
     <p:spTree>
       <p:nvGrpSpPr>
-        <p:cNvPr id="3001" name="s3-root"/>
+        <p:cNvPr id="1" name=""/>
         <p:cNvGrpSpPr/>
         <p:nvPr/>
       </p:nvGrpSpPr>
@@ -7436,7 +7592,9 @@
           <a:bodyPr xmlns:a="http://schemas.openxmlformats.org/drawingml/2006/main" lIns="0" tIns="0" rIns="0" bIns="0" anchor="t"/>
           <a:lstStyle xmlns:a="http://schemas.openxmlformats.org/drawingml/2006/main"/>
           <a:p xmlns:a="http://schemas.openxmlformats.org/drawingml/2006/main">
-            <a:pPr algn="l"/>
+            <a:pPr algn="l">
+              <a:buNone/>
+            </a:pPr>
             <a:r>
               <a:rPr sz="3000" b="1" i="0">
                 <a:solidFill>
@@ -7514,7 +7672,9 @@
           <a:bodyPr xmlns:a="http://schemas.openxmlformats.org/drawingml/2006/main" lIns="0" tIns="0" rIns="0" bIns="0" anchor="t"/>
           <a:lstStyle xmlns:a="http://schemas.openxmlformats.org/drawingml/2006/main"/>
           <a:p xmlns:a="http://schemas.openxmlformats.org/drawingml/2006/main">
-            <a:pPr algn="l"/>
+            <a:pPr algn="l">
+              <a:buNone/>
+            </a:pPr>
             <a:r>
               <a:rPr sz="900" b="0" i="0">
                 <a:solidFill>
@@ -7561,7 +7721,9 @@
           <a:bodyPr xmlns:a="http://schemas.openxmlformats.org/drawingml/2006/main" lIns="0" tIns="0" rIns="0" bIns="0" anchor="t"/>
           <a:lstStyle xmlns:a="http://schemas.openxmlformats.org/drawingml/2006/main"/>
           <a:p xmlns:a="http://schemas.openxmlformats.org/drawingml/2006/main">
-            <a:pPr algn="r"/>
+            <a:pPr algn="r">
+              <a:buNone/>
+            </a:pPr>
             <a:r>
               <a:rPr sz="900" b="0" i="0">
                 <a:solidFill>
@@ -7639,7 +7801,9 @@
           <a:bodyPr xmlns:a="http://schemas.openxmlformats.org/drawingml/2006/main" lIns="0" tIns="0" rIns="0" bIns="0" anchor="t"/>
           <a:lstStyle xmlns:a="http://schemas.openxmlformats.org/drawingml/2006/main"/>
           <a:p xmlns:a="http://schemas.openxmlformats.org/drawingml/2006/main">
-            <a:pPr algn="l"/>
+            <a:pPr algn="l">
+              <a:buNone/>
+            </a:pPr>
             <a:r>
               <a:rPr sz="1800" b="1" i="0">
                 <a:solidFill>
@@ -7649,7 +7813,7 @@
                 <a:ea typeface="NanumBarunGothicOTF"/>
                 <a:cs typeface="NanumBarunGothicOTF"/>
               </a:rPr>
-              <a:t>[두 과제를 함께 추진해야 하는 배경 또는 공통 목표]</a:t>
+              <a:t>[핵심 결론: 두 과제의 통합 추진 판단과 기대효과]</a:t>
             </a:r>
           </a:p>
         </p:txBody>
@@ -7812,7 +7976,9 @@
           <a:bodyPr xmlns:a="http://schemas.openxmlformats.org/drawingml/2006/main" lIns="0" tIns="0" rIns="0" bIns="0" anchor="t"/>
           <a:lstStyle xmlns:a="http://schemas.openxmlformats.org/drawingml/2006/main"/>
           <a:p xmlns:a="http://schemas.openxmlformats.org/drawingml/2006/main">
-            <a:pPr algn="ctr"/>
+            <a:pPr algn="ctr">
+              <a:buNone/>
+            </a:pPr>
             <a:r>
               <a:rPr sz="1700" b="1" i="0">
                 <a:solidFill>
@@ -7890,7 +8056,9 @@
           <a:bodyPr xmlns:a="http://schemas.openxmlformats.org/drawingml/2006/main" lIns="0" tIns="0" rIns="0" bIns="0" anchor="t"/>
           <a:lstStyle xmlns:a="http://schemas.openxmlformats.org/drawingml/2006/main"/>
           <a:p xmlns:a="http://schemas.openxmlformats.org/drawingml/2006/main">
-            <a:pPr algn="ctr"/>
+            <a:pPr algn="ctr">
+              <a:buNone/>
+            </a:pPr>
             <a:r>
               <a:rPr sz="1700" b="1" i="0">
                 <a:solidFill>
@@ -7937,7 +8105,9 @@
           <a:bodyPr xmlns:a="http://schemas.openxmlformats.org/drawingml/2006/main" lIns="0" tIns="0" rIns="0" bIns="0" anchor="t"/>
           <a:lstStyle xmlns:a="http://schemas.openxmlformats.org/drawingml/2006/main"/>
           <a:p xmlns:a="http://schemas.openxmlformats.org/drawingml/2006/main">
-            <a:pPr algn="ctr"/>
+            <a:pPr algn="ctr">
+              <a:buNone/>
+            </a:pPr>
             <a:r>
               <a:rPr sz="1100" b="1" i="0">
                 <a:solidFill>
@@ -7984,7 +8154,9 @@
           <a:bodyPr xmlns:a="http://schemas.openxmlformats.org/drawingml/2006/main" lIns="0" tIns="0" rIns="0" bIns="0" anchor="t"/>
           <a:lstStyle xmlns:a="http://schemas.openxmlformats.org/drawingml/2006/main"/>
           <a:p xmlns:a="http://schemas.openxmlformats.org/drawingml/2006/main">
-            <a:pPr algn="l"/>
+            <a:pPr algn="l">
+              <a:buNone/>
+            </a:pPr>
             <a:r>
               <a:rPr sz="1100" b="1" i="0">
                 <a:solidFill>
@@ -8031,7 +8203,9 @@
           <a:bodyPr xmlns:a="http://schemas.openxmlformats.org/drawingml/2006/main" lIns="0" tIns="0" rIns="0" bIns="0" anchor="t"/>
           <a:lstStyle xmlns:a="http://schemas.openxmlformats.org/drawingml/2006/main"/>
           <a:p xmlns:a="http://schemas.openxmlformats.org/drawingml/2006/main">
-            <a:pPr algn="l"/>
+            <a:pPr algn="l">
+              <a:buNone/>
+            </a:pPr>
             <a:r>
               <a:rPr sz="1500" b="1" i="0">
                 <a:solidFill>
@@ -8149,7 +8323,9 @@
           <a:bodyPr xmlns:a="http://schemas.openxmlformats.org/drawingml/2006/main" lIns="0" tIns="0" rIns="0" bIns="0" anchor="t"/>
           <a:lstStyle xmlns:a="http://schemas.openxmlformats.org/drawingml/2006/main"/>
           <a:p xmlns:a="http://schemas.openxmlformats.org/drawingml/2006/main">
-            <a:pPr algn="ctr"/>
+            <a:pPr algn="ctr">
+              <a:buNone/>
+            </a:pPr>
             <a:r>
               <a:rPr sz="2400" b="1" i="0">
                 <a:solidFill>
@@ -8227,7 +8403,9 @@
           <a:bodyPr xmlns:a="http://schemas.openxmlformats.org/drawingml/2006/main" lIns="0" tIns="0" rIns="0" bIns="0" anchor="t"/>
           <a:lstStyle xmlns:a="http://schemas.openxmlformats.org/drawingml/2006/main"/>
           <a:p xmlns:a="http://schemas.openxmlformats.org/drawingml/2006/main">
-            <a:pPr algn="l"/>
+            <a:pPr algn="l">
+              <a:buNone/>
+            </a:pPr>
             <a:r>
               <a:rPr sz="1100" b="1" i="0">
                 <a:solidFill>
@@ -8274,7 +8452,9 @@
           <a:bodyPr xmlns:a="http://schemas.openxmlformats.org/drawingml/2006/main" lIns="0" tIns="0" rIns="0" bIns="0" anchor="t"/>
           <a:lstStyle xmlns:a="http://schemas.openxmlformats.org/drawingml/2006/main"/>
           <a:p xmlns:a="http://schemas.openxmlformats.org/drawingml/2006/main">
-            <a:pPr algn="l"/>
+            <a:pPr algn="l">
+              <a:buNone/>
+            </a:pPr>
             <a:r>
               <a:rPr sz="1500" b="1" i="0">
                 <a:solidFill>
@@ -8423,7 +8603,9 @@
           <a:bodyPr xmlns:a="http://schemas.openxmlformats.org/drawingml/2006/main" lIns="0" tIns="0" rIns="0" bIns="0" anchor="t"/>
           <a:lstStyle xmlns:a="http://schemas.openxmlformats.org/drawingml/2006/main"/>
           <a:p xmlns:a="http://schemas.openxmlformats.org/drawingml/2006/main">
-            <a:pPr algn="ctr"/>
+            <a:pPr algn="ctr">
+              <a:buNone/>
+            </a:pPr>
             <a:r>
               <a:rPr sz="1000" b="1" i="0">
                 <a:solidFill>
@@ -8470,7 +8652,9 @@
           <a:bodyPr xmlns:a="http://schemas.openxmlformats.org/drawingml/2006/main" lIns="0" tIns="0" rIns="0" bIns="0" anchor="t"/>
           <a:lstStyle xmlns:a="http://schemas.openxmlformats.org/drawingml/2006/main"/>
           <a:p xmlns:a="http://schemas.openxmlformats.org/drawingml/2006/main">
-            <a:pPr algn="ctr"/>
+            <a:pPr algn="ctr">
+              <a:buNone/>
+            </a:pPr>
             <a:r>
               <a:rPr sz="1200" b="1" i="0">
                 <a:solidFill>
@@ -8579,7 +8763,9 @@
           <a:bodyPr xmlns:a="http://schemas.openxmlformats.org/drawingml/2006/main" lIns="0" tIns="0" rIns="0" bIns="0" anchor="t"/>
           <a:lstStyle xmlns:a="http://schemas.openxmlformats.org/drawingml/2006/main"/>
           <a:p xmlns:a="http://schemas.openxmlformats.org/drawingml/2006/main">
-            <a:pPr algn="ctr"/>
+            <a:pPr algn="ctr">
+              <a:buNone/>
+            </a:pPr>
             <a:r>
               <a:rPr sz="1700" b="1" i="0">
                 <a:solidFill>
@@ -8626,7 +8812,9 @@
           <a:bodyPr xmlns:a="http://schemas.openxmlformats.org/drawingml/2006/main" lIns="0" tIns="0" rIns="0" bIns="0" anchor="t"/>
           <a:lstStyle xmlns:a="http://schemas.openxmlformats.org/drawingml/2006/main"/>
           <a:p xmlns:a="http://schemas.openxmlformats.org/drawingml/2006/main">
-            <a:pPr algn="ctr"/>
+            <a:pPr algn="ctr">
+              <a:buNone/>
+            </a:pPr>
             <a:r>
               <a:rPr sz="1100" b="1" i="0">
                 <a:solidFill>
@@ -8673,7 +8861,9 @@
           <a:bodyPr xmlns:a="http://schemas.openxmlformats.org/drawingml/2006/main" lIns="0" tIns="0" rIns="0" bIns="0" anchor="t"/>
           <a:lstStyle xmlns:a="http://schemas.openxmlformats.org/drawingml/2006/main"/>
           <a:p xmlns:a="http://schemas.openxmlformats.org/drawingml/2006/main">
-            <a:pPr algn="l"/>
+            <a:pPr algn="l">
+              <a:buNone/>
+            </a:pPr>
             <a:r>
               <a:rPr sz="1100" b="1" i="0">
                 <a:solidFill>
@@ -8720,7 +8910,9 @@
           <a:bodyPr xmlns:a="http://schemas.openxmlformats.org/drawingml/2006/main" lIns="0" tIns="0" rIns="0" bIns="0" anchor="t"/>
           <a:lstStyle xmlns:a="http://schemas.openxmlformats.org/drawingml/2006/main"/>
           <a:p xmlns:a="http://schemas.openxmlformats.org/drawingml/2006/main">
-            <a:pPr algn="l"/>
+            <a:pPr algn="l">
+              <a:buNone/>
+            </a:pPr>
             <a:r>
               <a:rPr sz="1500" b="1" i="0">
                 <a:solidFill>
@@ -8838,7 +9030,9 @@
           <a:bodyPr xmlns:a="http://schemas.openxmlformats.org/drawingml/2006/main" lIns="0" tIns="0" rIns="0" bIns="0" anchor="t"/>
           <a:lstStyle xmlns:a="http://schemas.openxmlformats.org/drawingml/2006/main"/>
           <a:p xmlns:a="http://schemas.openxmlformats.org/drawingml/2006/main">
-            <a:pPr algn="ctr"/>
+            <a:pPr algn="ctr">
+              <a:buNone/>
+            </a:pPr>
             <a:r>
               <a:rPr sz="2400" b="1" i="0">
                 <a:solidFill>
@@ -8916,7 +9110,9 @@
           <a:bodyPr xmlns:a="http://schemas.openxmlformats.org/drawingml/2006/main" lIns="0" tIns="0" rIns="0" bIns="0" anchor="t"/>
           <a:lstStyle xmlns:a="http://schemas.openxmlformats.org/drawingml/2006/main"/>
           <a:p xmlns:a="http://schemas.openxmlformats.org/drawingml/2006/main">
-            <a:pPr algn="l"/>
+            <a:pPr algn="l">
+              <a:buNone/>
+            </a:pPr>
             <a:r>
               <a:rPr sz="1100" b="1" i="0">
                 <a:solidFill>
@@ -8963,7 +9159,9 @@
           <a:bodyPr xmlns:a="http://schemas.openxmlformats.org/drawingml/2006/main" lIns="0" tIns="0" rIns="0" bIns="0" anchor="t"/>
           <a:lstStyle xmlns:a="http://schemas.openxmlformats.org/drawingml/2006/main"/>
           <a:p xmlns:a="http://schemas.openxmlformats.org/drawingml/2006/main">
-            <a:pPr algn="l"/>
+            <a:pPr algn="l">
+              <a:buNone/>
+            </a:pPr>
             <a:r>
               <a:rPr sz="1500" b="1" i="0">
                 <a:solidFill>
@@ -9112,7 +9310,9 @@
           <a:bodyPr xmlns:a="http://schemas.openxmlformats.org/drawingml/2006/main" lIns="0" tIns="0" rIns="0" bIns="0" anchor="t"/>
           <a:lstStyle xmlns:a="http://schemas.openxmlformats.org/drawingml/2006/main"/>
           <a:p xmlns:a="http://schemas.openxmlformats.org/drawingml/2006/main">
-            <a:pPr algn="ctr"/>
+            <a:pPr algn="ctr">
+              <a:buNone/>
+            </a:pPr>
             <a:r>
               <a:rPr sz="1000" b="1" i="0">
                 <a:solidFill>
@@ -9159,7 +9359,9 @@
           <a:bodyPr xmlns:a="http://schemas.openxmlformats.org/drawingml/2006/main" lIns="0" tIns="0" rIns="0" bIns="0" anchor="t"/>
           <a:lstStyle xmlns:a="http://schemas.openxmlformats.org/drawingml/2006/main"/>
           <a:p xmlns:a="http://schemas.openxmlformats.org/drawingml/2006/main">
-            <a:pPr algn="ctr"/>
+            <a:pPr algn="ctr">
+              <a:buNone/>
+            </a:pPr>
             <a:r>
               <a:rPr sz="1200" b="1" i="0">
                 <a:solidFill>
@@ -9237,7 +9439,9 @@
           <a:bodyPr xmlns:a="http://schemas.openxmlformats.org/drawingml/2006/main" lIns="0" tIns="0" rIns="0" bIns="0" anchor="t"/>
           <a:lstStyle xmlns:a="http://schemas.openxmlformats.org/drawingml/2006/main"/>
           <a:p xmlns:a="http://schemas.openxmlformats.org/drawingml/2006/main">
-            <a:pPr algn="ctr"/>
+            <a:pPr algn="ctr">
+              <a:buNone/>
+            </a:pPr>
             <a:r>
               <a:rPr sz="1500" b="1" i="0">
                 <a:solidFill>
@@ -9315,7 +9519,9 @@
           <a:bodyPr xmlns:a="http://schemas.openxmlformats.org/drawingml/2006/main" lIns="0" tIns="0" rIns="0" bIns="0" anchor="t"/>
           <a:lstStyle xmlns:a="http://schemas.openxmlformats.org/drawingml/2006/main"/>
           <a:p xmlns:a="http://schemas.openxmlformats.org/drawingml/2006/main">
-            <a:pPr algn="ctr"/>
+            <a:pPr algn="ctr">
+              <a:buNone/>
+            </a:pPr>
             <a:r>
               <a:rPr sz="1100" b="1" i="0">
                 <a:solidFill>
@@ -9362,7 +9568,9 @@
           <a:bodyPr xmlns:a="http://schemas.openxmlformats.org/drawingml/2006/main" lIns="0" tIns="0" rIns="0" bIns="0" anchor="t"/>
           <a:lstStyle xmlns:a="http://schemas.openxmlformats.org/drawingml/2006/main"/>
           <a:p xmlns:a="http://schemas.openxmlformats.org/drawingml/2006/main">
-            <a:pPr algn="ctr"/>
+            <a:pPr algn="ctr">
+              <a:buNone/>
+            </a:pPr>
             <a:r>
               <a:rPr sz="2000" b="1" i="0">
                 <a:solidFill>
@@ -9409,7 +9617,9 @@
           <a:bodyPr xmlns:a="http://schemas.openxmlformats.org/drawingml/2006/main" lIns="0" tIns="0" rIns="0" bIns="0" anchor="t"/>
           <a:lstStyle xmlns:a="http://schemas.openxmlformats.org/drawingml/2006/main"/>
           <a:p xmlns:a="http://schemas.openxmlformats.org/drawingml/2006/main">
-            <a:pPr algn="ctr"/>
+            <a:pPr algn="ctr">
+              <a:buNone/>
+            </a:pPr>
             <a:r>
               <a:rPr sz="900" b="0" i="0">
                 <a:solidFill>
@@ -9456,7 +9666,9 @@
           <a:bodyPr xmlns:a="http://schemas.openxmlformats.org/drawingml/2006/main" lIns="0" tIns="0" rIns="0" bIns="0" anchor="t"/>
           <a:lstStyle xmlns:a="http://schemas.openxmlformats.org/drawingml/2006/main"/>
           <a:p xmlns:a="http://schemas.openxmlformats.org/drawingml/2006/main">
-            <a:pPr algn="ctr"/>
+            <a:pPr algn="ctr">
+              <a:buNone/>
+            </a:pPr>
             <a:r>
               <a:rPr sz="1100" b="1" i="0">
                 <a:solidFill>
@@ -9503,7 +9715,9 @@
           <a:bodyPr xmlns:a="http://schemas.openxmlformats.org/drawingml/2006/main" lIns="0" tIns="0" rIns="0" bIns="0" anchor="t"/>
           <a:lstStyle xmlns:a="http://schemas.openxmlformats.org/drawingml/2006/main"/>
           <a:p xmlns:a="http://schemas.openxmlformats.org/drawingml/2006/main">
-            <a:pPr algn="ctr"/>
+            <a:pPr algn="ctr">
+              <a:buNone/>
+            </a:pPr>
             <a:r>
               <a:rPr sz="2000" b="1" i="0">
                 <a:solidFill>
@@ -9550,7 +9764,9 @@
           <a:bodyPr xmlns:a="http://schemas.openxmlformats.org/drawingml/2006/main" lIns="0" tIns="0" rIns="0" bIns="0" anchor="t"/>
           <a:lstStyle xmlns:a="http://schemas.openxmlformats.org/drawingml/2006/main"/>
           <a:p xmlns:a="http://schemas.openxmlformats.org/drawingml/2006/main">
-            <a:pPr algn="ctr"/>
+            <a:pPr algn="ctr">
+              <a:buNone/>
+            </a:pPr>
             <a:r>
               <a:rPr sz="900" b="0" i="0">
                 <a:solidFill>
@@ -9597,7 +9813,9 @@
           <a:bodyPr xmlns:a="http://schemas.openxmlformats.org/drawingml/2006/main" lIns="0" tIns="0" rIns="0" bIns="0" anchor="t"/>
           <a:lstStyle xmlns:a="http://schemas.openxmlformats.org/drawingml/2006/main"/>
           <a:p xmlns:a="http://schemas.openxmlformats.org/drawingml/2006/main">
-            <a:pPr algn="ctr"/>
+            <a:pPr algn="ctr">
+              <a:buNone/>
+            </a:pPr>
             <a:r>
               <a:rPr sz="1100" b="1" i="0">
                 <a:solidFill>
@@ -9644,7 +9862,9 @@
           <a:bodyPr xmlns:a="http://schemas.openxmlformats.org/drawingml/2006/main" lIns="0" tIns="0" rIns="0" bIns="0" anchor="t"/>
           <a:lstStyle xmlns:a="http://schemas.openxmlformats.org/drawingml/2006/main"/>
           <a:p xmlns:a="http://schemas.openxmlformats.org/drawingml/2006/main">
-            <a:pPr algn="ctr"/>
+            <a:pPr algn="ctr">
+              <a:buNone/>
+            </a:pPr>
             <a:r>
               <a:rPr sz="2000" b="1" i="0">
                 <a:solidFill>
@@ -9691,7 +9911,9 @@
           <a:bodyPr xmlns:a="http://schemas.openxmlformats.org/drawingml/2006/main" lIns="0" tIns="0" rIns="0" bIns="0" anchor="t"/>
           <a:lstStyle xmlns:a="http://schemas.openxmlformats.org/drawingml/2006/main"/>
           <a:p xmlns:a="http://schemas.openxmlformats.org/drawingml/2006/main">
-            <a:pPr algn="ctr"/>
+            <a:pPr algn="ctr">
+              <a:buNone/>
+            </a:pPr>
             <a:r>
               <a:rPr sz="900" b="0" i="0">
                 <a:solidFill>
@@ -9738,7 +9960,9 @@
           <a:bodyPr xmlns:a="http://schemas.openxmlformats.org/drawingml/2006/main" lIns="0" tIns="0" rIns="0" bIns="0" anchor="t"/>
           <a:lstStyle xmlns:a="http://schemas.openxmlformats.org/drawingml/2006/main"/>
           <a:p xmlns:a="http://schemas.openxmlformats.org/drawingml/2006/main">
-            <a:pPr algn="ctr"/>
+            <a:pPr algn="ctr">
+              <a:buNone/>
+            </a:pPr>
             <a:r>
               <a:rPr sz="1100" b="1" i="0">
                 <a:solidFill>
@@ -9785,7 +10009,9 @@
           <a:bodyPr xmlns:a="http://schemas.openxmlformats.org/drawingml/2006/main" lIns="0" tIns="0" rIns="0" bIns="0" anchor="t"/>
           <a:lstStyle xmlns:a="http://schemas.openxmlformats.org/drawingml/2006/main"/>
           <a:p xmlns:a="http://schemas.openxmlformats.org/drawingml/2006/main">
-            <a:pPr algn="ctr"/>
+            <a:pPr algn="ctr">
+              <a:buNone/>
+            </a:pPr>
             <a:r>
               <a:rPr sz="2000" b="1" i="0">
                 <a:solidFill>
@@ -9832,7 +10058,9 @@
           <a:bodyPr xmlns:a="http://schemas.openxmlformats.org/drawingml/2006/main" lIns="0" tIns="0" rIns="0" bIns="0" anchor="t"/>
           <a:lstStyle xmlns:a="http://schemas.openxmlformats.org/drawingml/2006/main"/>
           <a:p xmlns:a="http://schemas.openxmlformats.org/drawingml/2006/main">
-            <a:pPr algn="ctr"/>
+            <a:pPr algn="ctr">
+              <a:buNone/>
+            </a:pPr>
             <a:r>
               <a:rPr sz="900" b="0" i="0">
                 <a:solidFill>
@@ -9869,7 +10097,7 @@
     </p:bg>
     <p:spTree>
       <p:nvGrpSpPr>
-        <p:cNvPr id="4001" name="s4-root"/>
+        <p:cNvPr id="1" name=""/>
         <p:cNvGrpSpPr/>
         <p:nvPr/>
       </p:nvGrpSpPr>
@@ -9972,7 +10200,9 @@
           <a:bodyPr xmlns:a="http://schemas.openxmlformats.org/drawingml/2006/main" lIns="0" tIns="0" rIns="0" bIns="0" anchor="t"/>
           <a:lstStyle xmlns:a="http://schemas.openxmlformats.org/drawingml/2006/main"/>
           <a:p xmlns:a="http://schemas.openxmlformats.org/drawingml/2006/main">
-            <a:pPr algn="l"/>
+            <a:pPr algn="l">
+              <a:buNone/>
+            </a:pPr>
             <a:r>
               <a:rPr sz="3000" b="1" i="0">
                 <a:solidFill>
@@ -10050,7 +10280,9 @@
           <a:bodyPr xmlns:a="http://schemas.openxmlformats.org/drawingml/2006/main" lIns="0" tIns="0" rIns="0" bIns="0" anchor="t"/>
           <a:lstStyle xmlns:a="http://schemas.openxmlformats.org/drawingml/2006/main"/>
           <a:p xmlns:a="http://schemas.openxmlformats.org/drawingml/2006/main">
-            <a:pPr algn="l"/>
+            <a:pPr algn="l">
+              <a:buNone/>
+            </a:pPr>
             <a:r>
               <a:rPr sz="900" b="0" i="0">
                 <a:solidFill>
@@ -10097,7 +10329,9 @@
           <a:bodyPr xmlns:a="http://schemas.openxmlformats.org/drawingml/2006/main" lIns="0" tIns="0" rIns="0" bIns="0" anchor="t"/>
           <a:lstStyle xmlns:a="http://schemas.openxmlformats.org/drawingml/2006/main"/>
           <a:p xmlns:a="http://schemas.openxmlformats.org/drawingml/2006/main">
-            <a:pPr algn="r"/>
+            <a:pPr algn="r">
+              <a:buNone/>
+            </a:pPr>
             <a:r>
               <a:rPr sz="900" b="0" i="0">
                 <a:solidFill>
@@ -10175,7 +10409,9 @@
           <a:bodyPr xmlns:a="http://schemas.openxmlformats.org/drawingml/2006/main" lIns="0" tIns="0" rIns="0" bIns="0" anchor="t"/>
           <a:lstStyle xmlns:a="http://schemas.openxmlformats.org/drawingml/2006/main"/>
           <a:p xmlns:a="http://schemas.openxmlformats.org/drawingml/2006/main">
-            <a:pPr algn="ctr"/>
+            <a:pPr algn="ctr">
+              <a:buNone/>
+            </a:pPr>
             <a:r>
               <a:rPr sz="1800" b="1" i="0">
                 <a:solidFill>
@@ -10253,7 +10489,9 @@
           <a:bodyPr xmlns:a="http://schemas.openxmlformats.org/drawingml/2006/main" lIns="0" tIns="0" rIns="0" bIns="0" anchor="t"/>
           <a:lstStyle xmlns:a="http://schemas.openxmlformats.org/drawingml/2006/main"/>
           <a:p xmlns:a="http://schemas.openxmlformats.org/drawingml/2006/main">
-            <a:pPr algn="ctr"/>
+            <a:pPr algn="ctr">
+              <a:buNone/>
+            </a:pPr>
             <a:r>
               <a:rPr sz="1800" b="1" i="0">
                 <a:solidFill>
@@ -10331,7 +10569,9 @@
           <a:bodyPr xmlns:a="http://schemas.openxmlformats.org/drawingml/2006/main" lIns="0" tIns="0" rIns="0" bIns="0" anchor="t"/>
           <a:lstStyle xmlns:a="http://schemas.openxmlformats.org/drawingml/2006/main"/>
           <a:p xmlns:a="http://schemas.openxmlformats.org/drawingml/2006/main">
-            <a:pPr algn="ctr"/>
+            <a:pPr algn="ctr">
+              <a:buNone/>
+            </a:pPr>
             <a:r>
               <a:rPr sz="1700" b="1" i="0">
                 <a:solidFill>
@@ -10378,7 +10618,9 @@
           <a:bodyPr xmlns:a="http://schemas.openxmlformats.org/drawingml/2006/main" lIns="0" tIns="0" rIns="0" bIns="0" anchor="t"/>
           <a:lstStyle xmlns:a="http://schemas.openxmlformats.org/drawingml/2006/main"/>
           <a:p xmlns:a="http://schemas.openxmlformats.org/drawingml/2006/main">
-            <a:pPr algn="l"/>
+            <a:pPr algn="l">
+              <a:buNone/>
+            </a:pPr>
             <a:r>
               <a:rPr sz="1900" b="1" i="0">
                 <a:solidFill>
@@ -10388,7 +10630,7 @@
                 <a:ea typeface="NanumBarunGothicOTF"/>
                 <a:cs typeface="NanumBarunGothicOTF"/>
               </a:rPr>
-              <a:t>[적용 범위 또는 추진 단계]</a:t>
+              <a:t>[핵심 결론: 적용 범위와 최종 기대효과]</a:t>
             </a:r>
           </a:p>
         </p:txBody>
@@ -10425,7 +10667,9 @@
           <a:bodyPr xmlns:a="http://schemas.openxmlformats.org/drawingml/2006/main" lIns="0" tIns="0" rIns="0" bIns="0" anchor="t"/>
           <a:lstStyle xmlns:a="http://schemas.openxmlformats.org/drawingml/2006/main"/>
           <a:p xmlns:a="http://schemas.openxmlformats.org/drawingml/2006/main">
-            <a:pPr algn="l"/>
+            <a:pPr algn="l">
+              <a:buNone/>
+            </a:pPr>
             <a:r>
               <a:rPr sz="1300" b="1" i="0">
                 <a:solidFill>
@@ -10472,7 +10716,9 @@
           <a:bodyPr xmlns:a="http://schemas.openxmlformats.org/drawingml/2006/main" lIns="0" tIns="0" rIns="0" bIns="0" anchor="t"/>
           <a:lstStyle xmlns:a="http://schemas.openxmlformats.org/drawingml/2006/main"/>
           <a:p xmlns:a="http://schemas.openxmlformats.org/drawingml/2006/main">
-            <a:pPr algn="ctr"/>
+            <a:pPr algn="ctr">
+              <a:buNone/>
+            </a:pPr>
             <a:r>
               <a:rPr sz="1700" b="1" i="0">
                 <a:solidFill>
@@ -10519,7 +10765,9 @@
           <a:bodyPr xmlns:a="http://schemas.openxmlformats.org/drawingml/2006/main" lIns="0" tIns="0" rIns="0" bIns="0" anchor="t"/>
           <a:lstStyle xmlns:a="http://schemas.openxmlformats.org/drawingml/2006/main"/>
           <a:p xmlns:a="http://schemas.openxmlformats.org/drawingml/2006/main">
-            <a:pPr algn="l"/>
+            <a:pPr algn="l">
+              <a:buNone/>
+            </a:pPr>
             <a:r>
               <a:rPr sz="1300" b="1" i="0">
                 <a:solidFill>
@@ -10566,7 +10814,9 @@
           <a:bodyPr xmlns:a="http://schemas.openxmlformats.org/drawingml/2006/main" lIns="0" tIns="0" rIns="0" bIns="0" anchor="t"/>
           <a:lstStyle xmlns:a="http://schemas.openxmlformats.org/drawingml/2006/main"/>
           <a:p xmlns:a="http://schemas.openxmlformats.org/drawingml/2006/main">
-            <a:pPr algn="ctr"/>
+            <a:pPr algn="ctr">
+              <a:buNone/>
+            </a:pPr>
             <a:r>
               <a:rPr sz="1700" b="1" i="0">
                 <a:solidFill>
@@ -10613,7 +10863,9 @@
           <a:bodyPr xmlns:a="http://schemas.openxmlformats.org/drawingml/2006/main" lIns="0" tIns="0" rIns="0" bIns="0" anchor="t"/>
           <a:lstStyle xmlns:a="http://schemas.openxmlformats.org/drawingml/2006/main"/>
           <a:p xmlns:a="http://schemas.openxmlformats.org/drawingml/2006/main">
-            <a:pPr algn="l"/>
+            <a:pPr algn="l">
+              <a:buNone/>
+            </a:pPr>
             <a:r>
               <a:rPr sz="1300" b="1" i="0">
                 <a:solidFill>
@@ -10759,7 +11011,9 @@
           <a:bodyPr xmlns:a="http://schemas.openxmlformats.org/drawingml/2006/main" lIns="0" tIns="0" rIns="0" bIns="0" anchor="t"/>
           <a:lstStyle xmlns:a="http://schemas.openxmlformats.org/drawingml/2006/main"/>
           <a:p xmlns:a="http://schemas.openxmlformats.org/drawingml/2006/main">
-            <a:pPr algn="ctr"/>
+            <a:pPr algn="ctr">
+              <a:buNone/>
+            </a:pPr>
             <a:r>
               <a:rPr sz="1000" b="0" i="0">
                 <a:solidFill>
@@ -10806,7 +11060,9 @@
           <a:bodyPr xmlns:a="http://schemas.openxmlformats.org/drawingml/2006/main" lIns="0" tIns="0" rIns="0" bIns="0" anchor="t"/>
           <a:lstStyle xmlns:a="http://schemas.openxmlformats.org/drawingml/2006/main"/>
           <a:p xmlns:a="http://schemas.openxmlformats.org/drawingml/2006/main">
-            <a:pPr algn="ctr"/>
+            <a:pPr algn="ctr">
+              <a:buNone/>
+            </a:pPr>
             <a:r>
               <a:rPr sz="1000" b="0" i="0">
                 <a:solidFill>
@@ -10853,7 +11109,9 @@
           <a:bodyPr xmlns:a="http://schemas.openxmlformats.org/drawingml/2006/main" lIns="0" tIns="0" rIns="0" bIns="0" anchor="t"/>
           <a:lstStyle xmlns:a="http://schemas.openxmlformats.org/drawingml/2006/main"/>
           <a:p xmlns:a="http://schemas.openxmlformats.org/drawingml/2006/main">
-            <a:pPr algn="ctr"/>
+            <a:pPr algn="ctr">
+              <a:buNone/>
+            </a:pPr>
             <a:r>
               <a:rPr sz="1000" b="0" i="0">
                 <a:solidFill>
@@ -10900,7 +11158,9 @@
           <a:bodyPr xmlns:a="http://schemas.openxmlformats.org/drawingml/2006/main" lIns="0" tIns="0" rIns="0" bIns="0" anchor="t"/>
           <a:lstStyle xmlns:a="http://schemas.openxmlformats.org/drawingml/2006/main"/>
           <a:p xmlns:a="http://schemas.openxmlformats.org/drawingml/2006/main">
-            <a:pPr algn="l"/>
+            <a:pPr algn="l">
+              <a:buNone/>
+            </a:pPr>
             <a:r>
               <a:rPr sz="1700" b="1" i="0">
                 <a:solidFill>
@@ -10947,7 +11207,9 @@
           <a:bodyPr xmlns:a="http://schemas.openxmlformats.org/drawingml/2006/main" lIns="0" tIns="0" rIns="0" bIns="0" anchor="t"/>
           <a:lstStyle xmlns:a="http://schemas.openxmlformats.org/drawingml/2006/main"/>
           <a:p xmlns:a="http://schemas.openxmlformats.org/drawingml/2006/main">
-            <a:pPr algn="l"/>
+            <a:pPr algn="l">
+              <a:buNone/>
+            </a:pPr>
             <a:r>
               <a:rPr sz="1300" b="0" i="0">
                 <a:solidFill>
@@ -11027,7 +11289,9 @@
           <a:bodyPr xmlns:a="http://schemas.openxmlformats.org/drawingml/2006/main" lIns="0" tIns="0" rIns="0" bIns="0" anchor="t"/>
           <a:lstStyle xmlns:a="http://schemas.openxmlformats.org/drawingml/2006/main"/>
           <a:p xmlns:a="http://schemas.openxmlformats.org/drawingml/2006/main">
-            <a:pPr algn="ctr"/>
+            <a:pPr algn="ctr">
+              <a:buNone/>
+            </a:pPr>
             <a:r>
               <a:rPr sz="1100" b="1" i="0">
                 <a:solidFill>
@@ -11074,7 +11338,9 @@
           <a:bodyPr xmlns:a="http://schemas.openxmlformats.org/drawingml/2006/main" lIns="0" tIns="0" rIns="0" bIns="0" anchor="t"/>
           <a:lstStyle xmlns:a="http://schemas.openxmlformats.org/drawingml/2006/main"/>
           <a:p xmlns:a="http://schemas.openxmlformats.org/drawingml/2006/main">
-            <a:pPr algn="l"/>
+            <a:pPr algn="l">
+              <a:buNone/>
+            </a:pPr>
             <a:r>
               <a:rPr sz="1700" b="1" i="0">
                 <a:solidFill>
@@ -11121,7 +11387,9 @@
           <a:bodyPr xmlns:a="http://schemas.openxmlformats.org/drawingml/2006/main" lIns="0" tIns="0" rIns="0" bIns="0" anchor="t"/>
           <a:lstStyle xmlns:a="http://schemas.openxmlformats.org/drawingml/2006/main"/>
           <a:p xmlns:a="http://schemas.openxmlformats.org/drawingml/2006/main">
-            <a:pPr algn="l"/>
+            <a:pPr algn="l">
+              <a:buNone/>
+            </a:pPr>
             <a:r>
               <a:rPr sz="1300" b="0" i="0">
                 <a:solidFill>
@@ -11201,7 +11469,9 @@
           <a:bodyPr xmlns:a="http://schemas.openxmlformats.org/drawingml/2006/main" lIns="0" tIns="0" rIns="0" bIns="0" anchor="t"/>
           <a:lstStyle xmlns:a="http://schemas.openxmlformats.org/drawingml/2006/main"/>
           <a:p xmlns:a="http://schemas.openxmlformats.org/drawingml/2006/main">
-            <a:pPr algn="ctr"/>
+            <a:pPr algn="ctr">
+              <a:buNone/>
+            </a:pPr>
             <a:r>
               <a:rPr sz="1100" b="1" i="0">
                 <a:solidFill>
@@ -11281,7 +11551,9 @@
           <a:bodyPr xmlns:a="http://schemas.openxmlformats.org/drawingml/2006/main" lIns="0" tIns="0" rIns="0" bIns="0" anchor="t"/>
           <a:lstStyle xmlns:a="http://schemas.openxmlformats.org/drawingml/2006/main"/>
           <a:p xmlns:a="http://schemas.openxmlformats.org/drawingml/2006/main">
-            <a:pPr algn="ctr"/>
+            <a:pPr algn="ctr">
+              <a:buNone/>
+            </a:pPr>
             <a:r>
               <a:rPr sz="1700" b="1" i="0">
                 <a:solidFill>
@@ -11329,7 +11601,7 @@
     </p:bg>
     <p:spTree>
       <p:nvGrpSpPr>
-        <p:cNvPr id="5001" name="s5-root"/>
+        <p:cNvPr id="1" name=""/>
         <p:cNvGrpSpPr/>
         <p:nvPr/>
       </p:nvGrpSpPr>
@@ -11432,7 +11704,9 @@
           <a:bodyPr xmlns:a="http://schemas.openxmlformats.org/drawingml/2006/main" lIns="0" tIns="0" rIns="0" bIns="0" anchor="t"/>
           <a:lstStyle xmlns:a="http://schemas.openxmlformats.org/drawingml/2006/main"/>
           <a:p xmlns:a="http://schemas.openxmlformats.org/drawingml/2006/main">
-            <a:pPr algn="l"/>
+            <a:pPr algn="l">
+              <a:buNone/>
+            </a:pPr>
             <a:r>
               <a:rPr sz="3000" b="1" i="0">
                 <a:solidFill>
@@ -11510,7 +11784,9 @@
           <a:bodyPr xmlns:a="http://schemas.openxmlformats.org/drawingml/2006/main" lIns="0" tIns="0" rIns="0" bIns="0" anchor="t"/>
           <a:lstStyle xmlns:a="http://schemas.openxmlformats.org/drawingml/2006/main"/>
           <a:p xmlns:a="http://schemas.openxmlformats.org/drawingml/2006/main">
-            <a:pPr algn="l"/>
+            <a:pPr algn="l">
+              <a:buNone/>
+            </a:pPr>
             <a:r>
               <a:rPr sz="900" b="0" i="0">
                 <a:solidFill>
@@ -11557,7 +11833,9 @@
           <a:bodyPr xmlns:a="http://schemas.openxmlformats.org/drawingml/2006/main" lIns="0" tIns="0" rIns="0" bIns="0" anchor="t"/>
           <a:lstStyle xmlns:a="http://schemas.openxmlformats.org/drawingml/2006/main"/>
           <a:p xmlns:a="http://schemas.openxmlformats.org/drawingml/2006/main">
-            <a:pPr algn="r"/>
+            <a:pPr algn="r">
+              <a:buNone/>
+            </a:pPr>
             <a:r>
               <a:rPr sz="900" b="0" i="0">
                 <a:solidFill>
@@ -11635,7 +11913,9 @@
           <a:bodyPr xmlns:a="http://schemas.openxmlformats.org/drawingml/2006/main" lIns="0" tIns="0" rIns="0" bIns="0" anchor="t"/>
           <a:lstStyle xmlns:a="http://schemas.openxmlformats.org/drawingml/2006/main"/>
           <a:p xmlns:a="http://schemas.openxmlformats.org/drawingml/2006/main">
-            <a:pPr algn="l"/>
+            <a:pPr algn="l">
+              <a:buNone/>
+            </a:pPr>
             <a:r>
               <a:rPr sz="1800" b="1" i="0">
                 <a:solidFill>
@@ -11645,7 +11925,7 @@
                 <a:ea typeface="NanumBarunGothicOTF"/>
                 <a:cs typeface="NanumBarunGothicOTF"/>
               </a:rPr>
-              <a:t>[두 가지 핵심 내용을 묶는 공통 배경 또는 질문]</a:t>
+              <a:t>[핵심 결론: 두 내용을 종합한 판단 또는 다음 조치]</a:t>
             </a:r>
           </a:p>
         </p:txBody>
@@ -11808,7 +12088,9 @@
           <a:bodyPr xmlns:a="http://schemas.openxmlformats.org/drawingml/2006/main" lIns="0" tIns="0" rIns="0" bIns="0" anchor="t"/>
           <a:lstStyle xmlns:a="http://schemas.openxmlformats.org/drawingml/2006/main"/>
           <a:p xmlns:a="http://schemas.openxmlformats.org/drawingml/2006/main">
-            <a:pPr algn="ctr"/>
+            <a:pPr algn="ctr">
+              <a:buNone/>
+            </a:pPr>
             <a:r>
               <a:rPr sz="1700" b="1" i="0">
                 <a:solidFill>
@@ -11855,7 +12137,9 @@
           <a:bodyPr xmlns:a="http://schemas.openxmlformats.org/drawingml/2006/main" lIns="0" tIns="0" rIns="0" bIns="0" anchor="t"/>
           <a:lstStyle xmlns:a="http://schemas.openxmlformats.org/drawingml/2006/main"/>
           <a:p xmlns:a="http://schemas.openxmlformats.org/drawingml/2006/main">
-            <a:pPr algn="l"/>
+            <a:pPr algn="l">
+              <a:buNone/>
+            </a:pPr>
             <a:r>
               <a:rPr sz="1700" b="1" i="0">
                 <a:solidFill>
@@ -12023,7 +12307,9 @@
           <a:bodyPr xmlns:a="http://schemas.openxmlformats.org/drawingml/2006/main" lIns="0" tIns="0" rIns="0" bIns="0" anchor="t"/>
           <a:lstStyle xmlns:a="http://schemas.openxmlformats.org/drawingml/2006/main"/>
           <a:p xmlns:a="http://schemas.openxmlformats.org/drawingml/2006/main">
-            <a:pPr algn="l"/>
+            <a:pPr algn="l">
+              <a:buNone/>
+            </a:pPr>
             <a:r>
               <a:rPr sz="1100" b="1" i="0">
                 <a:solidFill>
@@ -12070,7 +12356,9 @@
           <a:bodyPr xmlns:a="http://schemas.openxmlformats.org/drawingml/2006/main" lIns="0" tIns="0" rIns="0" bIns="0" anchor="t"/>
           <a:lstStyle xmlns:a="http://schemas.openxmlformats.org/drawingml/2006/main"/>
           <a:p xmlns:a="http://schemas.openxmlformats.org/drawingml/2006/main">
-            <a:pPr algn="l"/>
+            <a:pPr algn="l">
+              <a:buNone/>
+            </a:pPr>
             <a:r>
               <a:rPr sz="1200" b="1" i="0">
                 <a:solidFill>
@@ -12243,7 +12531,9 @@
           <a:bodyPr xmlns:a="http://schemas.openxmlformats.org/drawingml/2006/main" lIns="0" tIns="0" rIns="0" bIns="0" anchor="t"/>
           <a:lstStyle xmlns:a="http://schemas.openxmlformats.org/drawingml/2006/main"/>
           <a:p xmlns:a="http://schemas.openxmlformats.org/drawingml/2006/main">
-            <a:pPr algn="ctr"/>
+            <a:pPr algn="ctr">
+              <a:buNone/>
+            </a:pPr>
             <a:r>
               <a:rPr sz="1700" b="1" i="0">
                 <a:solidFill>
@@ -12290,7 +12580,9 @@
           <a:bodyPr xmlns:a="http://schemas.openxmlformats.org/drawingml/2006/main" lIns="0" tIns="0" rIns="0" bIns="0" anchor="t"/>
           <a:lstStyle xmlns:a="http://schemas.openxmlformats.org/drawingml/2006/main"/>
           <a:p xmlns:a="http://schemas.openxmlformats.org/drawingml/2006/main">
-            <a:pPr algn="l"/>
+            <a:pPr algn="l">
+              <a:buNone/>
+            </a:pPr>
             <a:r>
               <a:rPr sz="1700" b="1" i="0">
                 <a:solidFill>
@@ -12458,7 +12750,9 @@
           <a:bodyPr xmlns:a="http://schemas.openxmlformats.org/drawingml/2006/main" lIns="0" tIns="0" rIns="0" bIns="0" anchor="t"/>
           <a:lstStyle xmlns:a="http://schemas.openxmlformats.org/drawingml/2006/main"/>
           <a:p xmlns:a="http://schemas.openxmlformats.org/drawingml/2006/main">
-            <a:pPr algn="l"/>
+            <a:pPr algn="l">
+              <a:buNone/>
+            </a:pPr>
             <a:r>
               <a:rPr sz="1100" b="1" i="0">
                 <a:solidFill>
@@ -12505,7 +12799,9 @@
           <a:bodyPr xmlns:a="http://schemas.openxmlformats.org/drawingml/2006/main" lIns="0" tIns="0" rIns="0" bIns="0" anchor="t"/>
           <a:lstStyle xmlns:a="http://schemas.openxmlformats.org/drawingml/2006/main"/>
           <a:p xmlns:a="http://schemas.openxmlformats.org/drawingml/2006/main">
-            <a:pPr algn="l"/>
+            <a:pPr algn="l">
+              <a:buNone/>
+            </a:pPr>
             <a:r>
               <a:rPr sz="1200" b="1" i="0">
                 <a:solidFill>
@@ -12583,7 +12879,9 @@
           <a:bodyPr xmlns:a="http://schemas.openxmlformats.org/drawingml/2006/main" lIns="0" tIns="0" rIns="0" bIns="0" anchor="t"/>
           <a:lstStyle xmlns:a="http://schemas.openxmlformats.org/drawingml/2006/main"/>
           <a:p xmlns:a="http://schemas.openxmlformats.org/drawingml/2006/main">
-            <a:pPr algn="ctr"/>
+            <a:pPr algn="ctr">
+              <a:buNone/>
+            </a:pPr>
             <a:r>
               <a:rPr sz="1400" b="1" i="0">
                 <a:solidFill>
@@ -12631,7 +12929,7 @@
     </p:bg>
     <p:spTree>
       <p:nvGrpSpPr>
-        <p:cNvPr id="6001" name="s6-root"/>
+        <p:cNvPr id="1" name=""/>
         <p:cNvGrpSpPr/>
         <p:nvPr/>
       </p:nvGrpSpPr>
@@ -12734,7 +13032,9 @@
           <a:bodyPr xmlns:a="http://schemas.openxmlformats.org/drawingml/2006/main" lIns="0" tIns="0" rIns="0" bIns="0" anchor="t"/>
           <a:lstStyle xmlns:a="http://schemas.openxmlformats.org/drawingml/2006/main"/>
           <a:p xmlns:a="http://schemas.openxmlformats.org/drawingml/2006/main">
-            <a:pPr algn="l"/>
+            <a:pPr algn="l">
+              <a:buNone/>
+            </a:pPr>
             <a:r>
               <a:rPr sz="3000" b="1" i="0">
                 <a:solidFill>
@@ -12812,7 +13112,9 @@
           <a:bodyPr xmlns:a="http://schemas.openxmlformats.org/drawingml/2006/main" lIns="0" tIns="0" rIns="0" bIns="0" anchor="t"/>
           <a:lstStyle xmlns:a="http://schemas.openxmlformats.org/drawingml/2006/main"/>
           <a:p xmlns:a="http://schemas.openxmlformats.org/drawingml/2006/main">
-            <a:pPr algn="l"/>
+            <a:pPr algn="l">
+              <a:buNone/>
+            </a:pPr>
             <a:r>
               <a:rPr sz="1400" b="0" i="0">
                 <a:solidFill>
@@ -12859,7 +13161,9 @@
           <a:bodyPr xmlns:a="http://schemas.openxmlformats.org/drawingml/2006/main" lIns="0" tIns="0" rIns="0" bIns="0" anchor="t"/>
           <a:lstStyle xmlns:a="http://schemas.openxmlformats.org/drawingml/2006/main"/>
           <a:p xmlns:a="http://schemas.openxmlformats.org/drawingml/2006/main">
-            <a:pPr algn="l"/>
+            <a:pPr algn="l">
+              <a:buNone/>
+            </a:pPr>
             <a:r>
               <a:rPr sz="900" b="0" i="0">
                 <a:solidFill>
@@ -12906,7 +13210,9 @@
           <a:bodyPr xmlns:a="http://schemas.openxmlformats.org/drawingml/2006/main" lIns="0" tIns="0" rIns="0" bIns="0" anchor="t"/>
           <a:lstStyle xmlns:a="http://schemas.openxmlformats.org/drawingml/2006/main"/>
           <a:p xmlns:a="http://schemas.openxmlformats.org/drawingml/2006/main">
-            <a:pPr algn="r"/>
+            <a:pPr algn="r">
+              <a:buNone/>
+            </a:pPr>
             <a:r>
               <a:rPr sz="900" b="0" i="0">
                 <a:solidFill>
@@ -12953,7 +13259,9 @@
           <a:bodyPr xmlns:a="http://schemas.openxmlformats.org/drawingml/2006/main" lIns="0" tIns="0" rIns="0" bIns="0" anchor="t"/>
           <a:lstStyle xmlns:a="http://schemas.openxmlformats.org/drawingml/2006/main"/>
           <a:p xmlns:a="http://schemas.openxmlformats.org/drawingml/2006/main">
-            <a:pPr algn="l"/>
+            <a:pPr algn="l">
+              <a:buNone/>
+            </a:pPr>
             <a:r>
               <a:rPr sz="1500" b="1" i="0">
                 <a:solidFill>
@@ -12963,7 +13271,7 @@
                 <a:ea typeface="NanumBarunGothicOTF"/>
                 <a:cs typeface="NanumBarunGothicOTF"/>
               </a:rPr>
-              <a:t>■ [이 표가 검증하는 질문 또는 핵심 해석]</a:t>
+              <a:t>■ [핵심 결론: 이 표가 검증하는 판단 또는 해석]</a:t>
             </a:r>
           </a:p>
         </p:txBody>
@@ -13033,7 +13341,9 @@
           <a:bodyPr xmlns:a="http://schemas.openxmlformats.org/drawingml/2006/main" lIns="0" tIns="0" rIns="0" bIns="0" anchor="t"/>
           <a:lstStyle xmlns:a="http://schemas.openxmlformats.org/drawingml/2006/main"/>
           <a:p xmlns:a="http://schemas.openxmlformats.org/drawingml/2006/main">
-            <a:pPr algn="ctr"/>
+            <a:pPr algn="ctr">
+              <a:buNone/>
+            </a:pPr>
             <a:r>
               <a:rPr sz="1000" b="1" i="0">
                 <a:solidFill>
@@ -13113,7 +13423,9 @@
           <a:bodyPr xmlns:a="http://schemas.openxmlformats.org/drawingml/2006/main" lIns="0" tIns="0" rIns="0" bIns="0" anchor="t"/>
           <a:lstStyle xmlns:a="http://schemas.openxmlformats.org/drawingml/2006/main"/>
           <a:p xmlns:a="http://schemas.openxmlformats.org/drawingml/2006/main">
-            <a:pPr algn="ctr"/>
+            <a:pPr algn="ctr">
+              <a:buNone/>
+            </a:pPr>
             <a:r>
               <a:rPr sz="1000" b="1" i="0">
                 <a:solidFill>
@@ -13193,7 +13505,9 @@
           <a:bodyPr xmlns:a="http://schemas.openxmlformats.org/drawingml/2006/main" lIns="0" tIns="0" rIns="0" bIns="0" anchor="t"/>
           <a:lstStyle xmlns:a="http://schemas.openxmlformats.org/drawingml/2006/main"/>
           <a:p xmlns:a="http://schemas.openxmlformats.org/drawingml/2006/main">
-            <a:pPr algn="ctr"/>
+            <a:pPr algn="ctr">
+              <a:buNone/>
+            </a:pPr>
             <a:r>
               <a:rPr sz="1000" b="1" i="0">
                 <a:solidFill>
@@ -13273,7 +13587,9 @@
           <a:bodyPr xmlns:a="http://schemas.openxmlformats.org/drawingml/2006/main" lIns="0" tIns="0" rIns="0" bIns="0" anchor="t"/>
           <a:lstStyle xmlns:a="http://schemas.openxmlformats.org/drawingml/2006/main"/>
           <a:p xmlns:a="http://schemas.openxmlformats.org/drawingml/2006/main">
-            <a:pPr algn="ctr"/>
+            <a:pPr algn="ctr">
+              <a:buNone/>
+            </a:pPr>
             <a:r>
               <a:rPr sz="1000" b="1" i="0">
                 <a:solidFill>
@@ -13353,7 +13669,9 @@
           <a:bodyPr xmlns:a="http://schemas.openxmlformats.org/drawingml/2006/main" lIns="0" tIns="0" rIns="0" bIns="0" anchor="t"/>
           <a:lstStyle xmlns:a="http://schemas.openxmlformats.org/drawingml/2006/main"/>
           <a:p xmlns:a="http://schemas.openxmlformats.org/drawingml/2006/main">
-            <a:pPr algn="ctr"/>
+            <a:pPr algn="ctr">
+              <a:buNone/>
+            </a:pPr>
             <a:r>
               <a:rPr sz="1000" b="1" i="0">
                 <a:solidFill>
@@ -13433,7 +13751,9 @@
           <a:bodyPr xmlns:a="http://schemas.openxmlformats.org/drawingml/2006/main" lIns="0" tIns="0" rIns="0" bIns="0" anchor="t"/>
           <a:lstStyle xmlns:a="http://schemas.openxmlformats.org/drawingml/2006/main"/>
           <a:p xmlns:a="http://schemas.openxmlformats.org/drawingml/2006/main">
-            <a:pPr algn="ctr"/>
+            <a:pPr algn="ctr">
+              <a:buNone/>
+            </a:pPr>
             <a:r>
               <a:rPr sz="1000" b="1" i="0">
                 <a:solidFill>
@@ -13513,7 +13833,9 @@
           <a:bodyPr xmlns:a="http://schemas.openxmlformats.org/drawingml/2006/main" lIns="0" tIns="0" rIns="0" bIns="0" anchor="t"/>
           <a:lstStyle xmlns:a="http://schemas.openxmlformats.org/drawingml/2006/main"/>
           <a:p xmlns:a="http://schemas.openxmlformats.org/drawingml/2006/main">
-            <a:pPr algn="l"/>
+            <a:pPr algn="l">
+              <a:buNone/>
+            </a:pPr>
             <a:r>
               <a:rPr sz="1000" b="0" i="0">
                 <a:solidFill>
@@ -13593,7 +13915,9 @@
           <a:bodyPr xmlns:a="http://schemas.openxmlformats.org/drawingml/2006/main" lIns="0" tIns="0" rIns="0" bIns="0" anchor="t"/>
           <a:lstStyle xmlns:a="http://schemas.openxmlformats.org/drawingml/2006/main"/>
           <a:p xmlns:a="http://schemas.openxmlformats.org/drawingml/2006/main">
-            <a:pPr algn="l"/>
+            <a:pPr algn="l">
+              <a:buNone/>
+            </a:pPr>
             <a:r>
               <a:rPr sz="1000" b="0" i="0">
                 <a:solidFill>
@@ -13673,7 +13997,9 @@
           <a:bodyPr xmlns:a="http://schemas.openxmlformats.org/drawingml/2006/main" lIns="0" tIns="0" rIns="0" bIns="0" anchor="t"/>
           <a:lstStyle xmlns:a="http://schemas.openxmlformats.org/drawingml/2006/main"/>
           <a:p xmlns:a="http://schemas.openxmlformats.org/drawingml/2006/main">
-            <a:pPr algn="l"/>
+            <a:pPr algn="l">
+              <a:buNone/>
+            </a:pPr>
             <a:r>
               <a:rPr sz="1000" b="0" i="0">
                 <a:solidFill>
@@ -13753,7 +14079,9 @@
           <a:bodyPr xmlns:a="http://schemas.openxmlformats.org/drawingml/2006/main" lIns="0" tIns="0" rIns="0" bIns="0" anchor="t"/>
           <a:lstStyle xmlns:a="http://schemas.openxmlformats.org/drawingml/2006/main"/>
           <a:p xmlns:a="http://schemas.openxmlformats.org/drawingml/2006/main">
-            <a:pPr algn="l"/>
+            <a:pPr algn="l">
+              <a:buNone/>
+            </a:pPr>
             <a:r>
               <a:rPr sz="1000" b="0" i="0">
                 <a:solidFill>
@@ -13833,7 +14161,9 @@
           <a:bodyPr xmlns:a="http://schemas.openxmlformats.org/drawingml/2006/main" lIns="0" tIns="0" rIns="0" bIns="0" anchor="t"/>
           <a:lstStyle xmlns:a="http://schemas.openxmlformats.org/drawingml/2006/main"/>
           <a:p xmlns:a="http://schemas.openxmlformats.org/drawingml/2006/main">
-            <a:pPr algn="ctr"/>
+            <a:pPr algn="ctr">
+              <a:buNone/>
+            </a:pPr>
             <a:r>
               <a:rPr sz="1000" b="1" i="0">
                 <a:solidFill>
@@ -13913,7 +14243,9 @@
           <a:bodyPr xmlns:a="http://schemas.openxmlformats.org/drawingml/2006/main" lIns="0" tIns="0" rIns="0" bIns="0" anchor="t"/>
           <a:lstStyle xmlns:a="http://schemas.openxmlformats.org/drawingml/2006/main"/>
           <a:p xmlns:a="http://schemas.openxmlformats.org/drawingml/2006/main">
-            <a:pPr algn="l"/>
+            <a:pPr algn="l">
+              <a:buNone/>
+            </a:pPr>
             <a:r>
               <a:rPr sz="1000" b="0" i="0">
                 <a:solidFill>
@@ -13993,7 +14325,9 @@
           <a:bodyPr xmlns:a="http://schemas.openxmlformats.org/drawingml/2006/main" lIns="0" tIns="0" rIns="0" bIns="0" anchor="t"/>
           <a:lstStyle xmlns:a="http://schemas.openxmlformats.org/drawingml/2006/main"/>
           <a:p xmlns:a="http://schemas.openxmlformats.org/drawingml/2006/main">
-            <a:pPr algn="l"/>
+            <a:pPr algn="l">
+              <a:buNone/>
+            </a:pPr>
             <a:r>
               <a:rPr sz="1000" b="0" i="0">
                 <a:solidFill>
@@ -14073,7 +14407,9 @@
           <a:bodyPr xmlns:a="http://schemas.openxmlformats.org/drawingml/2006/main" lIns="0" tIns="0" rIns="0" bIns="0" anchor="t"/>
           <a:lstStyle xmlns:a="http://schemas.openxmlformats.org/drawingml/2006/main"/>
           <a:p xmlns:a="http://schemas.openxmlformats.org/drawingml/2006/main">
-            <a:pPr algn="l"/>
+            <a:pPr algn="l">
+              <a:buNone/>
+            </a:pPr>
             <a:r>
               <a:rPr sz="1000" b="0" i="0">
                 <a:solidFill>
@@ -14153,7 +14489,9 @@
           <a:bodyPr xmlns:a="http://schemas.openxmlformats.org/drawingml/2006/main" lIns="0" tIns="0" rIns="0" bIns="0" anchor="t"/>
           <a:lstStyle xmlns:a="http://schemas.openxmlformats.org/drawingml/2006/main"/>
           <a:p xmlns:a="http://schemas.openxmlformats.org/drawingml/2006/main">
-            <a:pPr algn="l"/>
+            <a:pPr algn="l">
+              <a:buNone/>
+            </a:pPr>
             <a:r>
               <a:rPr sz="1000" b="0" i="0">
                 <a:solidFill>
@@ -14233,7 +14571,9 @@
           <a:bodyPr xmlns:a="http://schemas.openxmlformats.org/drawingml/2006/main" lIns="0" tIns="0" rIns="0" bIns="0" anchor="t"/>
           <a:lstStyle xmlns:a="http://schemas.openxmlformats.org/drawingml/2006/main"/>
           <a:p xmlns:a="http://schemas.openxmlformats.org/drawingml/2006/main">
-            <a:pPr algn="ctr"/>
+            <a:pPr algn="ctr">
+              <a:buNone/>
+            </a:pPr>
             <a:r>
               <a:rPr sz="1000" b="1" i="0">
                 <a:solidFill>
@@ -14313,7 +14653,9 @@
           <a:bodyPr xmlns:a="http://schemas.openxmlformats.org/drawingml/2006/main" lIns="0" tIns="0" rIns="0" bIns="0" anchor="t"/>
           <a:lstStyle xmlns:a="http://schemas.openxmlformats.org/drawingml/2006/main"/>
           <a:p xmlns:a="http://schemas.openxmlformats.org/drawingml/2006/main">
-            <a:pPr algn="l"/>
+            <a:pPr algn="l">
+              <a:buNone/>
+            </a:pPr>
             <a:r>
               <a:rPr sz="1000" b="0" i="0">
                 <a:solidFill>
@@ -14393,7 +14735,9 @@
           <a:bodyPr xmlns:a="http://schemas.openxmlformats.org/drawingml/2006/main" lIns="0" tIns="0" rIns="0" bIns="0" anchor="t"/>
           <a:lstStyle xmlns:a="http://schemas.openxmlformats.org/drawingml/2006/main"/>
           <a:p xmlns:a="http://schemas.openxmlformats.org/drawingml/2006/main">
-            <a:pPr algn="l"/>
+            <a:pPr algn="l">
+              <a:buNone/>
+            </a:pPr>
             <a:r>
               <a:rPr sz="1000" b="0" i="0">
                 <a:solidFill>
@@ -14473,7 +14817,9 @@
           <a:bodyPr xmlns:a="http://schemas.openxmlformats.org/drawingml/2006/main" lIns="0" tIns="0" rIns="0" bIns="0" anchor="t"/>
           <a:lstStyle xmlns:a="http://schemas.openxmlformats.org/drawingml/2006/main"/>
           <a:p xmlns:a="http://schemas.openxmlformats.org/drawingml/2006/main">
-            <a:pPr algn="l"/>
+            <a:pPr algn="l">
+              <a:buNone/>
+            </a:pPr>
             <a:r>
               <a:rPr sz="1000" b="0" i="0">
                 <a:solidFill>
@@ -14553,7 +14899,9 @@
           <a:bodyPr xmlns:a="http://schemas.openxmlformats.org/drawingml/2006/main" lIns="0" tIns="0" rIns="0" bIns="0" anchor="t"/>
           <a:lstStyle xmlns:a="http://schemas.openxmlformats.org/drawingml/2006/main"/>
           <a:p xmlns:a="http://schemas.openxmlformats.org/drawingml/2006/main">
-            <a:pPr algn="l"/>
+            <a:pPr algn="l">
+              <a:buNone/>
+            </a:pPr>
             <a:r>
               <a:rPr sz="1000" b="0" i="0">
                 <a:solidFill>
@@ -14633,7 +14981,9 @@
           <a:bodyPr xmlns:a="http://schemas.openxmlformats.org/drawingml/2006/main" lIns="0" tIns="0" rIns="0" bIns="0" anchor="t"/>
           <a:lstStyle xmlns:a="http://schemas.openxmlformats.org/drawingml/2006/main"/>
           <a:p xmlns:a="http://schemas.openxmlformats.org/drawingml/2006/main">
-            <a:pPr algn="ctr"/>
+            <a:pPr algn="ctr">
+              <a:buNone/>
+            </a:pPr>
             <a:r>
               <a:rPr sz="1000" b="1" i="0">
                 <a:solidFill>
@@ -14713,7 +15063,9 @@
           <a:bodyPr xmlns:a="http://schemas.openxmlformats.org/drawingml/2006/main" lIns="0" tIns="0" rIns="0" bIns="0" anchor="t"/>
           <a:lstStyle xmlns:a="http://schemas.openxmlformats.org/drawingml/2006/main"/>
           <a:p xmlns:a="http://schemas.openxmlformats.org/drawingml/2006/main">
-            <a:pPr algn="l"/>
+            <a:pPr algn="l">
+              <a:buNone/>
+            </a:pPr>
             <a:r>
               <a:rPr sz="1000" b="0" i="0">
                 <a:solidFill>
@@ -14793,7 +15145,9 @@
           <a:bodyPr xmlns:a="http://schemas.openxmlformats.org/drawingml/2006/main" lIns="0" tIns="0" rIns="0" bIns="0" anchor="t"/>
           <a:lstStyle xmlns:a="http://schemas.openxmlformats.org/drawingml/2006/main"/>
           <a:p xmlns:a="http://schemas.openxmlformats.org/drawingml/2006/main">
-            <a:pPr algn="l"/>
+            <a:pPr algn="l">
+              <a:buNone/>
+            </a:pPr>
             <a:r>
               <a:rPr sz="1000" b="0" i="0">
                 <a:solidFill>
@@ -14873,7 +15227,9 @@
           <a:bodyPr xmlns:a="http://schemas.openxmlformats.org/drawingml/2006/main" lIns="0" tIns="0" rIns="0" bIns="0" anchor="t"/>
           <a:lstStyle xmlns:a="http://schemas.openxmlformats.org/drawingml/2006/main"/>
           <a:p xmlns:a="http://schemas.openxmlformats.org/drawingml/2006/main">
-            <a:pPr algn="l"/>
+            <a:pPr algn="l">
+              <a:buNone/>
+            </a:pPr>
             <a:r>
               <a:rPr sz="1000" b="0" i="0">
                 <a:solidFill>
@@ -14953,7 +15309,9 @@
           <a:bodyPr xmlns:a="http://schemas.openxmlformats.org/drawingml/2006/main" lIns="0" tIns="0" rIns="0" bIns="0" anchor="t"/>
           <a:lstStyle xmlns:a="http://schemas.openxmlformats.org/drawingml/2006/main"/>
           <a:p xmlns:a="http://schemas.openxmlformats.org/drawingml/2006/main">
-            <a:pPr algn="l"/>
+            <a:pPr algn="l">
+              <a:buNone/>
+            </a:pPr>
             <a:r>
               <a:rPr sz="1000" b="0" i="0">
                 <a:solidFill>
@@ -15000,7 +15358,9 @@
           <a:bodyPr xmlns:a="http://schemas.openxmlformats.org/drawingml/2006/main" lIns="0" tIns="0" rIns="0" bIns="0" anchor="t"/>
           <a:lstStyle xmlns:a="http://schemas.openxmlformats.org/drawingml/2006/main"/>
           <a:p xmlns:a="http://schemas.openxmlformats.org/drawingml/2006/main">
-            <a:pPr algn="l"/>
+            <a:pPr algn="l">
+              <a:buNone/>
+            </a:pPr>
             <a:r>
               <a:rPr sz="900" b="0" i="0">
                 <a:solidFill>
@@ -15010,7 +15370,7 @@
                 <a:ea typeface="NanumBarunGothicOTF"/>
                 <a:cs typeface="NanumBarunGothicOTF"/>
               </a:rPr>
-              <a:t>출처: [자료명]  |  기준일: YYYY.MM.DD  |  단위: [단위]</a:t>
+              <a:t>출처: [자료명]  |  기준일: YYYY-MM-DD  |  단위: [단위]</a:t>
             </a:r>
           </a:p>
         </p:txBody>
@@ -15078,7 +15438,9 @@
           <a:bodyPr xmlns:a="http://schemas.openxmlformats.org/drawingml/2006/main" lIns="0" tIns="0" rIns="0" bIns="0" anchor="t"/>
           <a:lstStyle xmlns:a="http://schemas.openxmlformats.org/drawingml/2006/main"/>
           <a:p xmlns:a="http://schemas.openxmlformats.org/drawingml/2006/main">
-            <a:pPr algn="l"/>
+            <a:pPr algn="l">
+              <a:buNone/>
+            </a:pPr>
             <a:r>
               <a:rPr sz="1400" b="1" i="0">
                 <a:solidFill>

</xml_diff>